<commit_message>
style: update all presentation fonts to Times New Roman
</commit_message>
<xml_diff>
--- a/Nuzzle_REST_API_Architecture.pptx
+++ b/Nuzzle_REST_API_Architecture.pptx
@@ -1684,33 +1684,6 @@
         </p:nvSpPr>
         <p:spPr>
           <a:xfrm>
-            <a:off x="6858000" y="-914400"/>
-            <a:ext cx="5943600" cy="5943600"/>
-          </a:xfrm>
-          <a:prstGeom prst="ellipse">
-            <a:avLst/>
-          </a:prstGeom>
-          <a:solidFill>
-            <a:srgbClr val="EDE7F6">
-              <a:alpha val="50000"/>
-            </a:srgbClr>
-          </a:solidFill>
-          <a:ln w="12700">
-            <a:solidFill>
-              <a:srgbClr val="FFFFFF"/>
-            </a:solidFill>
-            <a:prstDash val="solid"/>
-          </a:ln>
-        </p:spPr>
-      </p:sp>
-      <p:sp>
-        <p:nvSpPr>
-          <p:cNvPr id="3" name="Shape 1"/>
-          <p:cNvSpPr/>
-          <p:nvPr/>
-        </p:nvSpPr>
-        <p:spPr>
-          <a:xfrm>
             <a:off x="914400" y="1097280"/>
             <a:ext cx="2377440" cy="347472"/>
           </a:xfrm>
@@ -1730,7 +1703,7 @@
       </p:sp>
       <p:sp>
         <p:nvSpPr>
-          <p:cNvPr id="4" name="Text 2"/>
+          <p:cNvPr id="3" name="Text 1"/>
           <p:cNvSpPr/>
           <p:nvPr/>
         </p:nvSpPr>
@@ -1757,9 +1730,9 @@
                 <a:solidFill>
                   <a:srgbClr val="7C3AED"/>
                 </a:solidFill>
-                <a:latin typeface="Plus Jakarta Sans" pitchFamily="34" charset="0"/>
-                <a:ea typeface="Plus Jakarta Sans" pitchFamily="34" charset="-122"/>
-                <a:cs typeface="Plus Jakarta Sans" pitchFamily="34" charset="-120"/>
+                <a:latin typeface="Times New Roman" pitchFamily="34" charset="0"/>
+                <a:ea typeface="Times New Roman" pitchFamily="34" charset="-122"/>
+                <a:cs typeface="Times New Roman" pitchFamily="34" charset="-120"/>
               </a:rPr>
               <a:t>🐾 NUZZLE FULL-STACK v2.0</a:t>
             </a:r>
@@ -1769,7 +1742,7 @@
       </p:sp>
       <p:sp>
         <p:nvSpPr>
-          <p:cNvPr id="5" name="Text 3"/>
+          <p:cNvPr id="4" name="Text 2"/>
           <p:cNvSpPr/>
           <p:nvPr/>
         </p:nvSpPr>
@@ -1799,9 +1772,9 @@
                 <a:solidFill>
                   <a:srgbClr val="261E38"/>
                 </a:solidFill>
-                <a:latin typeface="Outfit" pitchFamily="34" charset="0"/>
-                <a:ea typeface="Outfit" pitchFamily="34" charset="-122"/>
-                <a:cs typeface="Outfit" pitchFamily="34" charset="-120"/>
+                <a:latin typeface="Times New Roman" pitchFamily="34" charset="0"/>
+                <a:ea typeface="Times New Roman" pitchFamily="34" charset="-122"/>
+                <a:cs typeface="Times New Roman" pitchFamily="34" charset="-120"/>
               </a:rPr>
               <a:t>RESTful API Architecture &amp;</a:t>
             </a:r>
@@ -1819,9 +1792,9 @@
                 <a:solidFill>
                   <a:srgbClr val="261E38"/>
                 </a:solidFill>
-                <a:latin typeface="Outfit" pitchFamily="34" charset="0"/>
-                <a:ea typeface="Outfit" pitchFamily="34" charset="-122"/>
-                <a:cs typeface="Outfit" pitchFamily="34" charset="-120"/>
+                <a:latin typeface="Times New Roman" pitchFamily="34" charset="0"/>
+                <a:ea typeface="Times New Roman" pitchFamily="34" charset="-122"/>
+                <a:cs typeface="Times New Roman" pitchFamily="34" charset="-120"/>
               </a:rPr>
               <a:t>Frontend-to-Backend Integration</a:t>
             </a:r>
@@ -1831,7 +1804,7 @@
       </p:sp>
       <p:sp>
         <p:nvSpPr>
-          <p:cNvPr id="6" name="Text 4"/>
+          <p:cNvPr id="5" name="Text 3"/>
           <p:cNvSpPr/>
           <p:nvPr/>
         </p:nvSpPr>
@@ -1861,9 +1834,9 @@
                 <a:solidFill>
                   <a:srgbClr val="5F5377"/>
                 </a:solidFill>
-                <a:latin typeface="Plus Jakarta Sans" pitchFamily="34" charset="0"/>
-                <a:ea typeface="Plus Jakarta Sans" pitchFamily="34" charset="-122"/>
-                <a:cs typeface="Plus Jakarta Sans" pitchFamily="34" charset="-120"/>
+                <a:latin typeface="Times New Roman" pitchFamily="34" charset="0"/>
+                <a:ea typeface="Times New Roman" pitchFamily="34" charset="-122"/>
+                <a:cs typeface="Times New Roman" pitchFamily="34" charset="-120"/>
               </a:rPr>
               <a:t>A decoupled, production-grade cloud architecture connecting a high-performance Vue 3 Client with a Next.js 16 REST Engine, Prisma 7 ORM, and Supabase PostgreSQL with real-time authentication.</a:t>
             </a:r>
@@ -1873,7 +1846,7 @@
       </p:sp>
       <p:sp>
         <p:nvSpPr>
-          <p:cNvPr id="7" name="Shape 5"/>
+          <p:cNvPr id="6" name="Shape 4"/>
           <p:cNvSpPr/>
           <p:nvPr/>
         </p:nvSpPr>
@@ -1898,7 +1871,7 @@
       </p:sp>
       <p:sp>
         <p:nvSpPr>
-          <p:cNvPr id="8" name="Text 6"/>
+          <p:cNvPr id="7" name="Text 5"/>
           <p:cNvSpPr/>
           <p:nvPr/>
         </p:nvSpPr>
@@ -1934,7 +1907,7 @@
       </p:sp>
       <p:sp>
         <p:nvSpPr>
-          <p:cNvPr id="9" name="Text 7"/>
+          <p:cNvPr id="8" name="Text 6"/>
           <p:cNvSpPr/>
           <p:nvPr/>
         </p:nvSpPr>
@@ -1961,9 +1934,9 @@
                 <a:solidFill>
                   <a:srgbClr val="261E38"/>
                 </a:solidFill>
-                <a:latin typeface="Outfit" pitchFamily="34" charset="0"/>
-                <a:ea typeface="Outfit" pitchFamily="34" charset="-122"/>
-                <a:cs typeface="Outfit" pitchFamily="34" charset="-120"/>
+                <a:latin typeface="Times New Roman" pitchFamily="34" charset="0"/>
+                <a:ea typeface="Times New Roman" pitchFamily="34" charset="-122"/>
+                <a:cs typeface="Times New Roman" pitchFamily="34" charset="-120"/>
               </a:rPr>
               <a:t>18+ REST Endpoints</a:t>
             </a:r>
@@ -1973,7 +1946,7 @@
       </p:sp>
       <p:sp>
         <p:nvSpPr>
-          <p:cNvPr id="10" name="Text 8"/>
+          <p:cNvPr id="9" name="Text 7"/>
           <p:cNvSpPr/>
           <p:nvPr/>
         </p:nvSpPr>
@@ -2000,9 +1973,9 @@
                 <a:solidFill>
                   <a:srgbClr val="5F5377"/>
                 </a:solidFill>
-                <a:latin typeface="Plus Jakarta Sans" pitchFamily="34" charset="0"/>
-                <a:ea typeface="Plus Jakarta Sans" pitchFamily="34" charset="-122"/>
-                <a:cs typeface="Plus Jakarta Sans" pitchFamily="34" charset="-120"/>
+                <a:latin typeface="Times New Roman" pitchFamily="34" charset="0"/>
+                <a:ea typeface="Times New Roman" pitchFamily="34" charset="-122"/>
+                <a:cs typeface="Times New Roman" pitchFamily="34" charset="-120"/>
               </a:rPr>
               <a:t>Auth, Feed, Radar, Vets &amp; PawAI</a:t>
             </a:r>
@@ -2012,7 +1985,7 @@
       </p:sp>
       <p:sp>
         <p:nvSpPr>
-          <p:cNvPr id="11" name="Shape 9"/>
+          <p:cNvPr id="10" name="Shape 8"/>
           <p:cNvSpPr/>
           <p:nvPr/>
         </p:nvSpPr>
@@ -2037,7 +2010,7 @@
       </p:sp>
       <p:sp>
         <p:nvSpPr>
-          <p:cNvPr id="12" name="Text 10"/>
+          <p:cNvPr id="11" name="Text 9"/>
           <p:cNvSpPr/>
           <p:nvPr/>
         </p:nvSpPr>
@@ -2073,7 +2046,7 @@
       </p:sp>
       <p:sp>
         <p:nvSpPr>
-          <p:cNvPr id="13" name="Text 11"/>
+          <p:cNvPr id="12" name="Text 10"/>
           <p:cNvSpPr/>
           <p:nvPr/>
         </p:nvSpPr>
@@ -2100,9 +2073,9 @@
                 <a:solidFill>
                   <a:srgbClr val="261E38"/>
                 </a:solidFill>
-                <a:latin typeface="Outfit" pitchFamily="34" charset="0"/>
-                <a:ea typeface="Outfit" pitchFamily="34" charset="-122"/>
-                <a:cs typeface="Outfit" pitchFamily="34" charset="-120"/>
+                <a:latin typeface="Times New Roman" pitchFamily="34" charset="0"/>
+                <a:ea typeface="Times New Roman" pitchFamily="34" charset="-122"/>
+                <a:cs typeface="Times New Roman" pitchFamily="34" charset="-120"/>
               </a:rPr>
               <a:t>Decoupled Client Layer</a:t>
             </a:r>
@@ -2112,7 +2085,7 @@
       </p:sp>
       <p:sp>
         <p:nvSpPr>
-          <p:cNvPr id="14" name="Text 12"/>
+          <p:cNvPr id="13" name="Text 11"/>
           <p:cNvSpPr/>
           <p:nvPr/>
         </p:nvSpPr>
@@ -2139,9 +2112,9 @@
                 <a:solidFill>
                   <a:srgbClr val="5F5377"/>
                 </a:solidFill>
-                <a:latin typeface="Plus Jakarta Sans" pitchFamily="34" charset="0"/>
-                <a:ea typeface="Plus Jakarta Sans" pitchFamily="34" charset="-122"/>
-                <a:cs typeface="Plus Jakarta Sans" pitchFamily="34" charset="-120"/>
+                <a:latin typeface="Times New Roman" pitchFamily="34" charset="0"/>
+                <a:ea typeface="Times New Roman" pitchFamily="34" charset="-122"/>
+                <a:cs typeface="Times New Roman" pitchFamily="34" charset="-120"/>
               </a:rPr>
               <a:t>Typed Axios/Fetch API Services</a:t>
             </a:r>
@@ -2151,7 +2124,7 @@
       </p:sp>
       <p:sp>
         <p:nvSpPr>
-          <p:cNvPr id="15" name="Shape 13"/>
+          <p:cNvPr id="14" name="Shape 12"/>
           <p:cNvSpPr/>
           <p:nvPr/>
         </p:nvSpPr>
@@ -2176,7 +2149,7 @@
       </p:sp>
       <p:sp>
         <p:nvSpPr>
-          <p:cNvPr id="16" name="Text 14"/>
+          <p:cNvPr id="15" name="Text 13"/>
           <p:cNvSpPr/>
           <p:nvPr/>
         </p:nvSpPr>
@@ -2212,7 +2185,7 @@
       </p:sp>
       <p:sp>
         <p:nvSpPr>
-          <p:cNvPr id="17" name="Text 15"/>
+          <p:cNvPr id="16" name="Text 14"/>
           <p:cNvSpPr/>
           <p:nvPr/>
         </p:nvSpPr>
@@ -2239,9 +2212,9 @@
                 <a:solidFill>
                   <a:srgbClr val="261E38"/>
                 </a:solidFill>
-                <a:latin typeface="Outfit" pitchFamily="34" charset="0"/>
-                <a:ea typeface="Outfit" pitchFamily="34" charset="-122"/>
-                <a:cs typeface="Outfit" pitchFamily="34" charset="-120"/>
+                <a:latin typeface="Times New Roman" pitchFamily="34" charset="0"/>
+                <a:ea typeface="Times New Roman" pitchFamily="34" charset="-122"/>
+                <a:cs typeface="Times New Roman" pitchFamily="34" charset="-120"/>
               </a:rPr>
               <a:t>PostgreSQL &amp; Supabase</a:t>
             </a:r>
@@ -2251,7 +2224,7 @@
       </p:sp>
       <p:sp>
         <p:nvSpPr>
-          <p:cNvPr id="18" name="Text 16"/>
+          <p:cNvPr id="17" name="Text 15"/>
           <p:cNvSpPr/>
           <p:nvPr/>
         </p:nvSpPr>
@@ -2278,9 +2251,9 @@
                 <a:solidFill>
                   <a:srgbClr val="5F5377"/>
                 </a:solidFill>
-                <a:latin typeface="Plus Jakarta Sans" pitchFamily="34" charset="0"/>
-                <a:ea typeface="Plus Jakarta Sans" pitchFamily="34" charset="-122"/>
-                <a:cs typeface="Plus Jakarta Sans" pitchFamily="34" charset="-120"/>
+                <a:latin typeface="Times New Roman" pitchFamily="34" charset="0"/>
+                <a:ea typeface="Times New Roman" pitchFamily="34" charset="-122"/>
+                <a:cs typeface="Times New Roman" pitchFamily="34" charset="-120"/>
               </a:rPr>
               <a:t>Prisma 7 with Connection Pooling</a:t>
             </a:r>
@@ -2290,7 +2263,7 @@
       </p:sp>
       <p:sp>
         <p:nvSpPr>
-          <p:cNvPr id="19" name="Shape 17"/>
+          <p:cNvPr id="18" name="Shape 16"/>
           <p:cNvSpPr/>
           <p:nvPr/>
         </p:nvSpPr>
@@ -2315,7 +2288,7 @@
       </p:sp>
       <p:sp>
         <p:nvSpPr>
-          <p:cNvPr id="20" name="Text 18"/>
+          <p:cNvPr id="19" name="Text 17"/>
           <p:cNvSpPr/>
           <p:nvPr/>
         </p:nvSpPr>
@@ -2342,9 +2315,9 @@
                 <a:solidFill>
                   <a:srgbClr val="947DEE"/>
                 </a:solidFill>
-                <a:latin typeface="Plus Jakarta Sans" pitchFamily="34" charset="0"/>
-                <a:ea typeface="Plus Jakarta Sans" pitchFamily="34" charset="-122"/>
-                <a:cs typeface="Plus Jakarta Sans" pitchFamily="34" charset="-120"/>
+                <a:latin typeface="Times New Roman" pitchFamily="34" charset="0"/>
+                <a:ea typeface="Times New Roman" pitchFamily="34" charset="-122"/>
+                <a:cs typeface="Times New Roman" pitchFamily="34" charset="-120"/>
               </a:rPr>
               <a:t>CORE ARCHITECTURE STACK</a:t>
             </a:r>
@@ -2354,7 +2327,7 @@
       </p:sp>
       <p:sp>
         <p:nvSpPr>
-          <p:cNvPr id="21" name="Shape 19"/>
+          <p:cNvPr id="20" name="Shape 18"/>
           <p:cNvSpPr/>
           <p:nvPr/>
         </p:nvSpPr>
@@ -2379,7 +2352,7 @@
       </p:sp>
       <p:sp>
         <p:nvSpPr>
-          <p:cNvPr id="22" name="Text 20"/>
+          <p:cNvPr id="21" name="Text 19"/>
           <p:cNvSpPr/>
           <p:nvPr/>
         </p:nvSpPr>
@@ -2406,9 +2379,9 @@
                 <a:solidFill>
                   <a:srgbClr val="9589B0"/>
                 </a:solidFill>
-                <a:latin typeface="Plus Jakarta Sans" pitchFamily="34" charset="0"/>
-                <a:ea typeface="Plus Jakarta Sans" pitchFamily="34" charset="-122"/>
-                <a:cs typeface="Plus Jakarta Sans" pitchFamily="34" charset="-120"/>
+                <a:latin typeface="Times New Roman" pitchFamily="34" charset="0"/>
+                <a:ea typeface="Times New Roman" pitchFamily="34" charset="-122"/>
+                <a:cs typeface="Times New Roman" pitchFamily="34" charset="-120"/>
               </a:rPr>
               <a:t>Frontend Client</a:t>
             </a:r>
@@ -2418,7 +2391,7 @@
       </p:sp>
       <p:sp>
         <p:nvSpPr>
-          <p:cNvPr id="23" name="Text 21"/>
+          <p:cNvPr id="22" name="Text 20"/>
           <p:cNvSpPr/>
           <p:nvPr/>
         </p:nvSpPr>
@@ -2445,9 +2418,9 @@
                 <a:solidFill>
                   <a:srgbClr val="947DEE"/>
                 </a:solidFill>
-                <a:latin typeface="Outfit" pitchFamily="34" charset="0"/>
-                <a:ea typeface="Outfit" pitchFamily="34" charset="-122"/>
-                <a:cs typeface="Outfit" pitchFamily="34" charset="-120"/>
+                <a:latin typeface="Times New Roman" pitchFamily="34" charset="0"/>
+                <a:ea typeface="Times New Roman" pitchFamily="34" charset="-122"/>
+                <a:cs typeface="Times New Roman" pitchFamily="34" charset="-120"/>
               </a:rPr>
               <a:t>Vue 3 + Vite + TypeScript</a:t>
             </a:r>
@@ -2457,7 +2430,7 @@
       </p:sp>
       <p:sp>
         <p:nvSpPr>
-          <p:cNvPr id="24" name="Shape 22"/>
+          <p:cNvPr id="23" name="Shape 21"/>
           <p:cNvSpPr/>
           <p:nvPr/>
         </p:nvSpPr>
@@ -2482,7 +2455,7 @@
       </p:sp>
       <p:sp>
         <p:nvSpPr>
-          <p:cNvPr id="25" name="Text 23"/>
+          <p:cNvPr id="24" name="Text 22"/>
           <p:cNvSpPr/>
           <p:nvPr/>
         </p:nvSpPr>
@@ -2509,9 +2482,9 @@
                 <a:solidFill>
                   <a:srgbClr val="9589B0"/>
                 </a:solidFill>
-                <a:latin typeface="Plus Jakarta Sans" pitchFamily="34" charset="0"/>
-                <a:ea typeface="Plus Jakarta Sans" pitchFamily="34" charset="-122"/>
-                <a:cs typeface="Plus Jakarta Sans" pitchFamily="34" charset="-120"/>
+                <a:latin typeface="Times New Roman" pitchFamily="34" charset="0"/>
+                <a:ea typeface="Times New Roman" pitchFamily="34" charset="-122"/>
+                <a:cs typeface="Times New Roman" pitchFamily="34" charset="-120"/>
               </a:rPr>
               <a:t>API Gateway</a:t>
             </a:r>
@@ -2521,7 +2494,7 @@
       </p:sp>
       <p:sp>
         <p:nvSpPr>
-          <p:cNvPr id="26" name="Text 24"/>
+          <p:cNvPr id="25" name="Text 23"/>
           <p:cNvSpPr/>
           <p:nvPr/>
         </p:nvSpPr>
@@ -2548,9 +2521,9 @@
                 <a:solidFill>
                   <a:srgbClr val="10B981"/>
                 </a:solidFill>
-                <a:latin typeface="Outfit" pitchFamily="34" charset="0"/>
-                <a:ea typeface="Outfit" pitchFamily="34" charset="-122"/>
-                <a:cs typeface="Outfit" pitchFamily="34" charset="-120"/>
+                <a:latin typeface="Times New Roman" pitchFamily="34" charset="0"/>
+                <a:ea typeface="Times New Roman" pitchFamily="34" charset="-122"/>
+                <a:cs typeface="Times New Roman" pitchFamily="34" charset="-120"/>
               </a:rPr>
               <a:t>Next.js 16 Route Handlers</a:t>
             </a:r>
@@ -2560,7 +2533,7 @@
       </p:sp>
       <p:sp>
         <p:nvSpPr>
-          <p:cNvPr id="27" name="Shape 25"/>
+          <p:cNvPr id="26" name="Shape 24"/>
           <p:cNvSpPr/>
           <p:nvPr/>
         </p:nvSpPr>
@@ -2585,7 +2558,7 @@
       </p:sp>
       <p:sp>
         <p:nvSpPr>
-          <p:cNvPr id="28" name="Text 26"/>
+          <p:cNvPr id="27" name="Text 25"/>
           <p:cNvSpPr/>
           <p:nvPr/>
         </p:nvSpPr>
@@ -2612,9 +2585,9 @@
                 <a:solidFill>
                   <a:srgbClr val="9589B0"/>
                 </a:solidFill>
-                <a:latin typeface="Plus Jakarta Sans" pitchFamily="34" charset="0"/>
-                <a:ea typeface="Plus Jakarta Sans" pitchFamily="34" charset="-122"/>
-                <a:cs typeface="Plus Jakarta Sans" pitchFamily="34" charset="-120"/>
+                <a:latin typeface="Times New Roman" pitchFamily="34" charset="0"/>
+                <a:ea typeface="Times New Roman" pitchFamily="34" charset="-122"/>
+                <a:cs typeface="Times New Roman" pitchFamily="34" charset="-120"/>
               </a:rPr>
               <a:t>Auth &amp; Security</a:t>
             </a:r>
@@ -2624,7 +2597,7 @@
       </p:sp>
       <p:sp>
         <p:nvSpPr>
-          <p:cNvPr id="29" name="Text 27"/>
+          <p:cNvPr id="28" name="Text 26"/>
           <p:cNvSpPr/>
           <p:nvPr/>
         </p:nvSpPr>
@@ -2651,9 +2624,9 @@
                 <a:solidFill>
                   <a:srgbClr val="F43F5E"/>
                 </a:solidFill>
-                <a:latin typeface="Outfit" pitchFamily="34" charset="0"/>
-                <a:ea typeface="Outfit" pitchFamily="34" charset="-122"/>
-                <a:cs typeface="Outfit" pitchFamily="34" charset="-120"/>
+                <a:latin typeface="Times New Roman" pitchFamily="34" charset="0"/>
+                <a:ea typeface="Times New Roman" pitchFamily="34" charset="-122"/>
+                <a:cs typeface="Times New Roman" pitchFamily="34" charset="-120"/>
               </a:rPr>
               <a:t>Supabase JWT (Bearer Token)</a:t>
             </a:r>
@@ -2663,7 +2636,7 @@
       </p:sp>
       <p:sp>
         <p:nvSpPr>
-          <p:cNvPr id="30" name="Shape 28"/>
+          <p:cNvPr id="29" name="Shape 27"/>
           <p:cNvSpPr/>
           <p:nvPr/>
         </p:nvSpPr>
@@ -2688,7 +2661,7 @@
       </p:sp>
       <p:sp>
         <p:nvSpPr>
-          <p:cNvPr id="31" name="Text 29"/>
+          <p:cNvPr id="30" name="Text 28"/>
           <p:cNvSpPr/>
           <p:nvPr/>
         </p:nvSpPr>
@@ -2715,9 +2688,9 @@
                 <a:solidFill>
                   <a:srgbClr val="9589B0"/>
                 </a:solidFill>
-                <a:latin typeface="Plus Jakarta Sans" pitchFamily="34" charset="0"/>
-                <a:ea typeface="Plus Jakarta Sans" pitchFamily="34" charset="-122"/>
-                <a:cs typeface="Plus Jakarta Sans" pitchFamily="34" charset="-120"/>
+                <a:latin typeface="Times New Roman" pitchFamily="34" charset="0"/>
+                <a:ea typeface="Times New Roman" pitchFamily="34" charset="-122"/>
+                <a:cs typeface="Times New Roman" pitchFamily="34" charset="-120"/>
               </a:rPr>
               <a:t>Data Layer</a:t>
             </a:r>
@@ -2727,7 +2700,7 @@
       </p:sp>
       <p:sp>
         <p:nvSpPr>
-          <p:cNvPr id="32" name="Text 30"/>
+          <p:cNvPr id="31" name="Text 29"/>
           <p:cNvSpPr/>
           <p:nvPr/>
         </p:nvSpPr>
@@ -2754,9 +2727,9 @@
                 <a:solidFill>
                   <a:srgbClr val="38BDF8"/>
                 </a:solidFill>
-                <a:latin typeface="Outfit" pitchFamily="34" charset="0"/>
-                <a:ea typeface="Outfit" pitchFamily="34" charset="-122"/>
-                <a:cs typeface="Outfit" pitchFamily="34" charset="-120"/>
+                <a:latin typeface="Times New Roman" pitchFamily="34" charset="0"/>
+                <a:ea typeface="Times New Roman" pitchFamily="34" charset="-122"/>
+                <a:cs typeface="Times New Roman" pitchFamily="34" charset="-120"/>
               </a:rPr>
               <a:t>Prisma 7 + PostgreSQL Pooler</a:t>
             </a:r>
@@ -2766,7 +2739,7 @@
       </p:sp>
       <p:sp>
         <p:nvSpPr>
-          <p:cNvPr id="33" name="Shape 31"/>
+          <p:cNvPr id="32" name="Shape 30"/>
           <p:cNvSpPr/>
           <p:nvPr/>
         </p:nvSpPr>
@@ -2791,7 +2764,7 @@
       </p:sp>
       <p:sp>
         <p:nvSpPr>
-          <p:cNvPr id="34" name="Text 32"/>
+          <p:cNvPr id="33" name="Text 31"/>
           <p:cNvSpPr/>
           <p:nvPr/>
         </p:nvSpPr>
@@ -2818,9 +2791,9 @@
                 <a:solidFill>
                   <a:srgbClr val="9589B0"/>
                 </a:solidFill>
-                <a:latin typeface="Plus Jakarta Sans" pitchFamily="34" charset="0"/>
-                <a:ea typeface="Plus Jakarta Sans" pitchFamily="34" charset="-122"/>
-                <a:cs typeface="Plus Jakarta Sans" pitchFamily="34" charset="-120"/>
+                <a:latin typeface="Times New Roman" pitchFamily="34" charset="0"/>
+                <a:ea typeface="Times New Roman" pitchFamily="34" charset="-122"/>
+                <a:cs typeface="Times New Roman" pitchFamily="34" charset="-120"/>
               </a:rPr>
               <a:t>AI Intelligence</a:t>
             </a:r>
@@ -2830,7 +2803,7 @@
       </p:sp>
       <p:sp>
         <p:nvSpPr>
-          <p:cNvPr id="35" name="Text 33"/>
+          <p:cNvPr id="34" name="Text 32"/>
           <p:cNvSpPr/>
           <p:nvPr/>
         </p:nvSpPr>
@@ -2857,9 +2830,9 @@
                 <a:solidFill>
                   <a:srgbClr val="F59E0B"/>
                 </a:solidFill>
-                <a:latin typeface="Outfit" pitchFamily="34" charset="0"/>
-                <a:ea typeface="Outfit" pitchFamily="34" charset="-122"/>
-                <a:cs typeface="Outfit" pitchFamily="34" charset="-120"/>
+                <a:latin typeface="Times New Roman" pitchFamily="34" charset="0"/>
+                <a:ea typeface="Times New Roman" pitchFamily="34" charset="-122"/>
+                <a:cs typeface="Times New Roman" pitchFamily="34" charset="-120"/>
               </a:rPr>
               <a:t>PawDoctor 24/7 Clinical Triage</a:t>
             </a:r>
@@ -2869,7 +2842,7 @@
       </p:sp>
       <p:sp>
         <p:nvSpPr>
-          <p:cNvPr id="36" name="Shape 34"/>
+          <p:cNvPr id="35" name="Shape 33"/>
           <p:cNvSpPr/>
           <p:nvPr/>
         </p:nvSpPr>
@@ -2894,7 +2867,7 @@
       </p:sp>
       <p:sp>
         <p:nvSpPr>
-          <p:cNvPr id="37" name="Text 35"/>
+          <p:cNvPr id="36" name="Text 34"/>
           <p:cNvSpPr/>
           <p:nvPr/>
         </p:nvSpPr>
@@ -2921,9 +2894,9 @@
                 <a:solidFill>
                   <a:srgbClr val="9589B0"/>
                 </a:solidFill>
-                <a:latin typeface="Plus Jakarta Sans" pitchFamily="34" charset="0"/>
-                <a:ea typeface="Plus Jakarta Sans" pitchFamily="34" charset="-122"/>
-                <a:cs typeface="Plus Jakarta Sans" pitchFamily="34" charset="-120"/>
+                <a:latin typeface="Times New Roman" pitchFamily="34" charset="0"/>
+                <a:ea typeface="Times New Roman" pitchFamily="34" charset="-122"/>
+                <a:cs typeface="Times New Roman" pitchFamily="34" charset="-120"/>
               </a:rPr>
               <a:t>Deployment</a:t>
             </a:r>
@@ -2933,7 +2906,7 @@
       </p:sp>
       <p:sp>
         <p:nvSpPr>
-          <p:cNvPr id="38" name="Text 36"/>
+          <p:cNvPr id="37" name="Text 35"/>
           <p:cNvSpPr/>
           <p:nvPr/>
         </p:nvSpPr>
@@ -2960,9 +2933,9 @@
                 <a:solidFill>
                   <a:srgbClr val="A78BFA"/>
                 </a:solidFill>
-                <a:latin typeface="Outfit" pitchFamily="34" charset="0"/>
-                <a:ea typeface="Outfit" pitchFamily="34" charset="-122"/>
-                <a:cs typeface="Outfit" pitchFamily="34" charset="-120"/>
+                <a:latin typeface="Times New Roman" pitchFamily="34" charset="0"/>
+                <a:ea typeface="Times New Roman" pitchFamily="34" charset="-122"/>
+                <a:cs typeface="Times New Roman" pitchFamily="34" charset="-120"/>
               </a:rPr>
               <a:t>Vercel Serverless + Netlify Edge</a:t>
             </a:r>
@@ -2972,7 +2945,7 @@
       </p:sp>
       <p:sp>
         <p:nvSpPr>
-          <p:cNvPr id="39" name="Text 37"/>
+          <p:cNvPr id="38" name="Text 36"/>
           <p:cNvSpPr/>
           <p:nvPr/>
         </p:nvSpPr>
@@ -2999,9 +2972,9 @@
                 <a:solidFill>
                   <a:srgbClr val="9589B0"/>
                 </a:solidFill>
-                <a:latin typeface="Plus Jakarta Sans" pitchFamily="34" charset="0"/>
-                <a:ea typeface="Plus Jakarta Sans" pitchFamily="34" charset="-122"/>
-                <a:cs typeface="Plus Jakarta Sans" pitchFamily="34" charset="-120"/>
+                <a:latin typeface="Times New Roman" pitchFamily="34" charset="0"/>
+                <a:ea typeface="Times New Roman" pitchFamily="34" charset="-122"/>
+                <a:cs typeface="Times New Roman" pitchFamily="34" charset="-120"/>
               </a:rPr>
               <a:t>Technopreneurship 2026 • Abu Zafor, Nadim Rahman, Rizvi Sarker</a:t>
             </a:r>
@@ -3095,9 +3068,9 @@
                 <a:solidFill>
                   <a:srgbClr val="7C3AED"/>
                 </a:solidFill>
-                <a:latin typeface="Outfit" pitchFamily="34" charset="0"/>
-                <a:ea typeface="Outfit" pitchFamily="34" charset="-122"/>
-                <a:cs typeface="Outfit" pitchFamily="34" charset="-120"/>
+                <a:latin typeface="Times New Roman" pitchFamily="34" charset="0"/>
+                <a:ea typeface="Times New Roman" pitchFamily="34" charset="-122"/>
+                <a:cs typeface="Times New Roman" pitchFamily="34" charset="-120"/>
               </a:rPr>
               <a:t>🐾 Nuzzle Engine</a:t>
             </a:r>
@@ -3134,9 +3107,9 @@
                 <a:solidFill>
                   <a:srgbClr val="5F5377"/>
                 </a:solidFill>
-                <a:latin typeface="Plus Jakarta Sans" pitchFamily="34" charset="0"/>
-                <a:ea typeface="Plus Jakarta Sans" pitchFamily="34" charset="-122"/>
-                <a:cs typeface="Plus Jakarta Sans" pitchFamily="34" charset="-120"/>
+                <a:latin typeface="Times New Roman" pitchFamily="34" charset="0"/>
+                <a:ea typeface="Times New Roman" pitchFamily="34" charset="-122"/>
+                <a:cs typeface="Times New Roman" pitchFamily="34" charset="-120"/>
               </a:rPr>
               <a:t>Slide 10 / 10 • Full-Stack REST API Architecture</a:t>
             </a:r>
@@ -3173,9 +3146,9 @@
                 <a:solidFill>
                   <a:srgbClr val="7C3AED"/>
                 </a:solidFill>
-                <a:latin typeface="Plus Jakarta Sans" pitchFamily="34" charset="0"/>
-                <a:ea typeface="Plus Jakarta Sans" pitchFamily="34" charset="-122"/>
-                <a:cs typeface="Plus Jakarta Sans" pitchFamily="34" charset="-120"/>
+                <a:latin typeface="Times New Roman" pitchFamily="34" charset="0"/>
+                <a:ea typeface="Times New Roman" pitchFamily="34" charset="-122"/>
+                <a:cs typeface="Times New Roman" pitchFamily="34" charset="-120"/>
               </a:rPr>
               <a:t>PRODUCTION INFRASTRUCTURE</a:t>
             </a:r>
@@ -3212,9 +3185,9 @@
                 <a:solidFill>
                   <a:srgbClr val="261E38"/>
                 </a:solidFill>
-                <a:latin typeface="Outfit" pitchFamily="34" charset="0"/>
-                <a:ea typeface="Outfit" pitchFamily="34" charset="-122"/>
-                <a:cs typeface="Outfit" pitchFamily="34" charset="-120"/>
+                <a:latin typeface="Times New Roman" pitchFamily="34" charset="0"/>
+                <a:ea typeface="Times New Roman" pitchFamily="34" charset="-122"/>
+                <a:cs typeface="Times New Roman" pitchFamily="34" charset="-120"/>
               </a:rPr>
               <a:t>Cloud Deployment Topology &amp; Full-Stack Summary</a:t>
             </a:r>
@@ -3274,9 +3247,9 @@
                 <a:solidFill>
                   <a:srgbClr val="9589B0"/>
                 </a:solidFill>
-                <a:latin typeface="Plus Jakarta Sans" pitchFamily="34" charset="0"/>
-                <a:ea typeface="Plus Jakarta Sans" pitchFamily="34" charset="-122"/>
-                <a:cs typeface="Plus Jakarta Sans" pitchFamily="34" charset="-120"/>
+                <a:latin typeface="Times New Roman" pitchFamily="34" charset="0"/>
+                <a:ea typeface="Times New Roman" pitchFamily="34" charset="-122"/>
+                <a:cs typeface="Times New Roman" pitchFamily="34" charset="-120"/>
               </a:rPr>
               <a:t>Nuzzle API v2.0 • Abu Zafor, Nadim Rahman, Rizvi Sarker • Technopreneurship 2026</a:t>
             </a:r>
@@ -3338,9 +3311,9 @@
                 <a:solidFill>
                   <a:srgbClr val="7C3AED"/>
                 </a:solidFill>
-                <a:latin typeface="Plus Jakarta Sans" pitchFamily="34" charset="0"/>
-                <a:ea typeface="Plus Jakarta Sans" pitchFamily="34" charset="-122"/>
-                <a:cs typeface="Plus Jakarta Sans" pitchFamily="34" charset="-120"/>
+                <a:latin typeface="Times New Roman" pitchFamily="34" charset="0"/>
+                <a:ea typeface="Times New Roman" pitchFamily="34" charset="-122"/>
+                <a:cs typeface="Times New Roman" pitchFamily="34" charset="-120"/>
               </a:rPr>
               <a:t>PRODUCTION CLOUD TOPOLOGY</a:t>
             </a:r>
@@ -3438,9 +3411,9 @@
                 <a:solidFill>
                   <a:srgbClr val="9589B0"/>
                 </a:solidFill>
-                <a:latin typeface="Plus Jakarta Sans" pitchFamily="34" charset="0"/>
-                <a:ea typeface="Plus Jakarta Sans" pitchFamily="34" charset="-122"/>
-                <a:cs typeface="Plus Jakarta Sans" pitchFamily="34" charset="-120"/>
+                <a:latin typeface="Times New Roman" pitchFamily="34" charset="0"/>
+                <a:ea typeface="Times New Roman" pitchFamily="34" charset="-122"/>
+                <a:cs typeface="Times New Roman" pitchFamily="34" charset="-120"/>
               </a:rPr>
               <a:t>Frontend Hosting</a:t>
             </a:r>
@@ -3477,9 +3450,9 @@
                 <a:solidFill>
                   <a:srgbClr val="261E38"/>
                 </a:solidFill>
-                <a:latin typeface="Outfit" pitchFamily="34" charset="0"/>
-                <a:ea typeface="Outfit" pitchFamily="34" charset="-122"/>
-                <a:cs typeface="Outfit" pitchFamily="34" charset="-120"/>
+                <a:latin typeface="Times New Roman" pitchFamily="34" charset="0"/>
+                <a:ea typeface="Times New Roman" pitchFamily="34" charset="-122"/>
+                <a:cs typeface="Times New Roman" pitchFamily="34" charset="-120"/>
               </a:rPr>
               <a:t>Vercel / Netlify (SPA Rewrites via vercel.json)</a:t>
             </a:r>
@@ -3577,9 +3550,9 @@
                 <a:solidFill>
                   <a:srgbClr val="9589B0"/>
                 </a:solidFill>
-                <a:latin typeface="Plus Jakarta Sans" pitchFamily="34" charset="0"/>
-                <a:ea typeface="Plus Jakarta Sans" pitchFamily="34" charset="-122"/>
-                <a:cs typeface="Plus Jakarta Sans" pitchFamily="34" charset="-120"/>
+                <a:latin typeface="Times New Roman" pitchFamily="34" charset="0"/>
+                <a:ea typeface="Times New Roman" pitchFamily="34" charset="-122"/>
+                <a:cs typeface="Times New Roman" pitchFamily="34" charset="-120"/>
               </a:rPr>
               <a:t>Backend API Engine</a:t>
             </a:r>
@@ -3616,9 +3589,9 @@
                 <a:solidFill>
                   <a:srgbClr val="261E38"/>
                 </a:solidFill>
-                <a:latin typeface="Outfit" pitchFamily="34" charset="0"/>
-                <a:ea typeface="Outfit" pitchFamily="34" charset="-122"/>
-                <a:cs typeface="Outfit" pitchFamily="34" charset="-120"/>
+                <a:latin typeface="Times New Roman" pitchFamily="34" charset="0"/>
+                <a:ea typeface="Times New Roman" pitchFamily="34" charset="-122"/>
+                <a:cs typeface="Times New Roman" pitchFamily="34" charset="-120"/>
               </a:rPr>
               <a:t>Vercel Serverless Functions (Next.js 16)</a:t>
             </a:r>
@@ -3716,9 +3689,9 @@
                 <a:solidFill>
                   <a:srgbClr val="9589B0"/>
                 </a:solidFill>
-                <a:latin typeface="Plus Jakarta Sans" pitchFamily="34" charset="0"/>
-                <a:ea typeface="Plus Jakarta Sans" pitchFamily="34" charset="-122"/>
-                <a:cs typeface="Plus Jakarta Sans" pitchFamily="34" charset="-120"/>
+                <a:latin typeface="Times New Roman" pitchFamily="34" charset="0"/>
+                <a:ea typeface="Times New Roman" pitchFamily="34" charset="-122"/>
+                <a:cs typeface="Times New Roman" pitchFamily="34" charset="-120"/>
               </a:rPr>
               <a:t>Database Cloud</a:t>
             </a:r>
@@ -3755,9 +3728,9 @@
                 <a:solidFill>
                   <a:srgbClr val="261E38"/>
                 </a:solidFill>
-                <a:latin typeface="Outfit" pitchFamily="34" charset="0"/>
-                <a:ea typeface="Outfit" pitchFamily="34" charset="-122"/>
-                <a:cs typeface="Outfit" pitchFamily="34" charset="-120"/>
+                <a:latin typeface="Times New Roman" pitchFamily="34" charset="0"/>
+                <a:ea typeface="Times New Roman" pitchFamily="34" charset="-122"/>
+                <a:cs typeface="Times New Roman" pitchFamily="34" charset="-120"/>
               </a:rPr>
               <a:t>Supabase PostgreSQL (18 Models Synchronized)</a:t>
             </a:r>
@@ -3855,9 +3828,9 @@
                 <a:solidFill>
                   <a:srgbClr val="9589B0"/>
                 </a:solidFill>
-                <a:latin typeface="Plus Jakarta Sans" pitchFamily="34" charset="0"/>
-                <a:ea typeface="Plus Jakarta Sans" pitchFamily="34" charset="-122"/>
-                <a:cs typeface="Plus Jakarta Sans" pitchFamily="34" charset="-120"/>
+                <a:latin typeface="Times New Roman" pitchFamily="34" charset="0"/>
+                <a:ea typeface="Times New Roman" pitchFamily="34" charset="-122"/>
+                <a:cs typeface="Times New Roman" pitchFamily="34" charset="-120"/>
               </a:rPr>
               <a:t>Authentication</a:t>
             </a:r>
@@ -3894,9 +3867,9 @@
                 <a:solidFill>
                   <a:srgbClr val="261E38"/>
                 </a:solidFill>
-                <a:latin typeface="Outfit" pitchFamily="34" charset="0"/>
-                <a:ea typeface="Outfit" pitchFamily="34" charset="-122"/>
-                <a:cs typeface="Outfit" pitchFamily="34" charset="-120"/>
+                <a:latin typeface="Times New Roman" pitchFamily="34" charset="0"/>
+                <a:ea typeface="Times New Roman" pitchFamily="34" charset="-122"/>
+                <a:cs typeface="Times New Roman" pitchFamily="34" charset="-120"/>
               </a:rPr>
               <a:t>Supabase Auth (JWT Bearer Token Flow)</a:t>
             </a:r>
@@ -3958,9 +3931,9 @@
                 <a:solidFill>
                   <a:srgbClr val="7C3AED"/>
                 </a:solidFill>
-                <a:latin typeface="Plus Jakarta Sans" pitchFamily="34" charset="0"/>
-                <a:ea typeface="Plus Jakarta Sans" pitchFamily="34" charset="-122"/>
-                <a:cs typeface="Plus Jakarta Sans" pitchFamily="34" charset="-120"/>
+                <a:latin typeface="Times New Roman" pitchFamily="34" charset="0"/>
+                <a:ea typeface="Times New Roman" pitchFamily="34" charset="-122"/>
+                <a:cs typeface="Times New Roman" pitchFamily="34" charset="-120"/>
               </a:rPr>
               <a:t>FULL-STACK REPOSITORIES &amp; METRICS</a:t>
             </a:r>
@@ -4022,9 +3995,9 @@
                 <a:solidFill>
                   <a:srgbClr val="7C3AED"/>
                 </a:solidFill>
-                <a:latin typeface="Outfit" pitchFamily="34" charset="0"/>
-                <a:ea typeface="Outfit" pitchFamily="34" charset="-122"/>
-                <a:cs typeface="Outfit" pitchFamily="34" charset="-120"/>
+                <a:latin typeface="Times New Roman" pitchFamily="34" charset="0"/>
+                <a:ea typeface="Times New Roman" pitchFamily="34" charset="-122"/>
+                <a:cs typeface="Times New Roman" pitchFamily="34" charset="-120"/>
               </a:rPr>
               <a:t>18+</a:t>
             </a:r>
@@ -4061,9 +4034,9 @@
                 <a:solidFill>
                   <a:srgbClr val="5F5377"/>
                 </a:solidFill>
-                <a:latin typeface="Plus Jakarta Sans" pitchFamily="34" charset="0"/>
-                <a:ea typeface="Plus Jakarta Sans" pitchFamily="34" charset="-122"/>
-                <a:cs typeface="Plus Jakarta Sans" pitchFamily="34" charset="-120"/>
+                <a:latin typeface="Times New Roman" pitchFamily="34" charset="0"/>
+                <a:ea typeface="Times New Roman" pitchFamily="34" charset="-122"/>
+                <a:cs typeface="Times New Roman" pitchFamily="34" charset="-120"/>
               </a:rPr>
               <a:t>REST Route Handlers</a:t>
             </a:r>
@@ -4125,9 +4098,9 @@
                 <a:solidFill>
                   <a:srgbClr val="10B981"/>
                 </a:solidFill>
-                <a:latin typeface="Outfit" pitchFamily="34" charset="0"/>
-                <a:ea typeface="Outfit" pitchFamily="34" charset="-122"/>
-                <a:cs typeface="Outfit" pitchFamily="34" charset="-120"/>
+                <a:latin typeface="Times New Roman" pitchFamily="34" charset="0"/>
+                <a:ea typeface="Times New Roman" pitchFamily="34" charset="-122"/>
+                <a:cs typeface="Times New Roman" pitchFamily="34" charset="-120"/>
               </a:rPr>
               <a:t>18</a:t>
             </a:r>
@@ -4164,9 +4137,9 @@
                 <a:solidFill>
                   <a:srgbClr val="5F5377"/>
                 </a:solidFill>
-                <a:latin typeface="Plus Jakarta Sans" pitchFamily="34" charset="0"/>
-                <a:ea typeface="Plus Jakarta Sans" pitchFamily="34" charset="-122"/>
-                <a:cs typeface="Plus Jakarta Sans" pitchFamily="34" charset="-120"/>
+                <a:latin typeface="Times New Roman" pitchFamily="34" charset="0"/>
+                <a:ea typeface="Times New Roman" pitchFamily="34" charset="-122"/>
+                <a:cs typeface="Times New Roman" pitchFamily="34" charset="-120"/>
               </a:rPr>
               <a:t>Database Models</a:t>
             </a:r>
@@ -4228,9 +4201,9 @@
                 <a:solidFill>
                   <a:srgbClr val="6366F1"/>
                 </a:solidFill>
-                <a:latin typeface="Outfit" pitchFamily="34" charset="0"/>
-                <a:ea typeface="Outfit" pitchFamily="34" charset="-122"/>
-                <a:cs typeface="Outfit" pitchFamily="34" charset="-120"/>
+                <a:latin typeface="Times New Roman" pitchFamily="34" charset="0"/>
+                <a:ea typeface="Times New Roman" pitchFamily="34" charset="-122"/>
+                <a:cs typeface="Times New Roman" pitchFamily="34" charset="-120"/>
               </a:rPr>
               <a:t>3</a:t>
             </a:r>
@@ -4267,9 +4240,9 @@
                 <a:solidFill>
                   <a:srgbClr val="5F5377"/>
                 </a:solidFill>
-                <a:latin typeface="Plus Jakarta Sans" pitchFamily="34" charset="0"/>
-                <a:ea typeface="Plus Jakarta Sans" pitchFamily="34" charset="-122"/>
-                <a:cs typeface="Plus Jakarta Sans" pitchFamily="34" charset="-120"/>
+                <a:latin typeface="Times New Roman" pitchFamily="34" charset="0"/>
+                <a:ea typeface="Times New Roman" pitchFamily="34" charset="-122"/>
+                <a:cs typeface="Times New Roman" pitchFamily="34" charset="-120"/>
               </a:rPr>
               <a:t>User Roles (Parent/Store/Vet)</a:t>
             </a:r>
@@ -4331,9 +4304,9 @@
                 <a:solidFill>
                   <a:srgbClr val="F43F5E"/>
                 </a:solidFill>
-                <a:latin typeface="Outfit" pitchFamily="34" charset="0"/>
-                <a:ea typeface="Outfit" pitchFamily="34" charset="-122"/>
-                <a:cs typeface="Outfit" pitchFamily="34" charset="-120"/>
+                <a:latin typeface="Times New Roman" pitchFamily="34" charset="0"/>
+                <a:ea typeface="Times New Roman" pitchFamily="34" charset="-122"/>
+                <a:cs typeface="Times New Roman" pitchFamily="34" charset="-120"/>
               </a:rPr>
               <a:t>100%</a:t>
             </a:r>
@@ -4370,9 +4343,9 @@
                 <a:solidFill>
                   <a:srgbClr val="5F5377"/>
                 </a:solidFill>
-                <a:latin typeface="Plus Jakarta Sans" pitchFamily="34" charset="0"/>
-                <a:ea typeface="Plus Jakarta Sans" pitchFamily="34" charset="-122"/>
-                <a:cs typeface="Plus Jakarta Sans" pitchFamily="34" charset="-120"/>
+                <a:latin typeface="Times New Roman" pitchFamily="34" charset="0"/>
+                <a:ea typeface="Times New Roman" pitchFamily="34" charset="-122"/>
+                <a:cs typeface="Times New Roman" pitchFamily="34" charset="-120"/>
               </a:rPr>
               <a:t>Type-Safe (TypeScript)</a:t>
             </a:r>
@@ -4434,9 +4407,9 @@
                 <a:solidFill>
                   <a:srgbClr val="7C3AED"/>
                 </a:solidFill>
-                <a:latin typeface="Plus Jakarta Sans" pitchFamily="34" charset="0"/>
-                <a:ea typeface="Plus Jakarta Sans" pitchFamily="34" charset="-122"/>
-                <a:cs typeface="Plus Jakarta Sans" pitchFamily="34" charset="-120"/>
+                <a:latin typeface="Times New Roman" pitchFamily="34" charset="0"/>
+                <a:ea typeface="Times New Roman" pitchFamily="34" charset="-122"/>
+                <a:cs typeface="Times New Roman" pitchFamily="34" charset="-120"/>
               </a:rPr>
               <a:t>📦 GITHUB REPOSITORIES:</a:t>
             </a:r>
@@ -4612,9 +4585,9 @@
                 <a:solidFill>
                   <a:srgbClr val="7C3AED"/>
                 </a:solidFill>
-                <a:latin typeface="Outfit" pitchFamily="34" charset="0"/>
-                <a:ea typeface="Outfit" pitchFamily="34" charset="-122"/>
-                <a:cs typeface="Outfit" pitchFamily="34" charset="-120"/>
+                <a:latin typeface="Times New Roman" pitchFamily="34" charset="0"/>
+                <a:ea typeface="Times New Roman" pitchFamily="34" charset="-122"/>
+                <a:cs typeface="Times New Roman" pitchFamily="34" charset="-120"/>
               </a:rPr>
               <a:t>🐾 Nuzzle Engine</a:t>
             </a:r>
@@ -4651,9 +4624,9 @@
                 <a:solidFill>
                   <a:srgbClr val="5F5377"/>
                 </a:solidFill>
-                <a:latin typeface="Plus Jakarta Sans" pitchFamily="34" charset="0"/>
-                <a:ea typeface="Plus Jakarta Sans" pitchFamily="34" charset="-122"/>
-                <a:cs typeface="Plus Jakarta Sans" pitchFamily="34" charset="-120"/>
+                <a:latin typeface="Times New Roman" pitchFamily="34" charset="0"/>
+                <a:ea typeface="Times New Roman" pitchFamily="34" charset="-122"/>
+                <a:cs typeface="Times New Roman" pitchFamily="34" charset="-120"/>
               </a:rPr>
               <a:t>Slide 2 / 10 • Full-Stack REST API Architecture</a:t>
             </a:r>
@@ -4690,9 +4663,9 @@
                 <a:solidFill>
                   <a:srgbClr val="7C3AED"/>
                 </a:solidFill>
-                <a:latin typeface="Plus Jakarta Sans" pitchFamily="34" charset="0"/>
-                <a:ea typeface="Plus Jakarta Sans" pitchFamily="34" charset="-122"/>
-                <a:cs typeface="Plus Jakarta Sans" pitchFamily="34" charset="-120"/>
+                <a:latin typeface="Times New Roman" pitchFamily="34" charset="0"/>
+                <a:ea typeface="Times New Roman" pitchFamily="34" charset="-122"/>
+                <a:cs typeface="Times New Roman" pitchFamily="34" charset="-120"/>
               </a:rPr>
               <a:t>SYSTEM DESIGN &amp; ARCHITECTURE</a:t>
             </a:r>
@@ -4729,9 +4702,9 @@
                 <a:solidFill>
                   <a:srgbClr val="261E38"/>
                 </a:solidFill>
-                <a:latin typeface="Outfit" pitchFamily="34" charset="0"/>
-                <a:ea typeface="Outfit" pitchFamily="34" charset="-122"/>
-                <a:cs typeface="Outfit" pitchFamily="34" charset="-120"/>
+                <a:latin typeface="Times New Roman" pitchFamily="34" charset="0"/>
+                <a:ea typeface="Times New Roman" pitchFamily="34" charset="-122"/>
+                <a:cs typeface="Times New Roman" pitchFamily="34" charset="-120"/>
               </a:rPr>
               <a:t>Decoupled Three-Tier Full-Stack Infrastructure</a:t>
             </a:r>
@@ -4791,9 +4764,9 @@
                 <a:solidFill>
                   <a:srgbClr val="9589B0"/>
                 </a:solidFill>
-                <a:latin typeface="Plus Jakarta Sans" pitchFamily="34" charset="0"/>
-                <a:ea typeface="Plus Jakarta Sans" pitchFamily="34" charset="-122"/>
-                <a:cs typeface="Plus Jakarta Sans" pitchFamily="34" charset="-120"/>
+                <a:latin typeface="Times New Roman" pitchFamily="34" charset="0"/>
+                <a:ea typeface="Times New Roman" pitchFamily="34" charset="-122"/>
+                <a:cs typeface="Times New Roman" pitchFamily="34" charset="-120"/>
               </a:rPr>
               <a:t>Nuzzle API v2.0 • Abu Zafor, Nadim Rahman, Rizvi Sarker • Technopreneurship 2026</a:t>
             </a:r>
@@ -4880,9 +4853,9 @@
                 <a:solidFill>
                   <a:srgbClr val="15803D"/>
                 </a:solidFill>
-                <a:latin typeface="Plus Jakarta Sans" pitchFamily="34" charset="0"/>
-                <a:ea typeface="Plus Jakarta Sans" pitchFamily="34" charset="-122"/>
-                <a:cs typeface="Plus Jakarta Sans" pitchFamily="34" charset="-120"/>
+                <a:latin typeface="Times New Roman" pitchFamily="34" charset="0"/>
+                <a:ea typeface="Times New Roman" pitchFamily="34" charset="-122"/>
+                <a:cs typeface="Times New Roman" pitchFamily="34" charset="-120"/>
               </a:rPr>
               <a:t>TIER 1</a:t>
             </a:r>
@@ -4919,9 +4892,9 @@
                 <a:solidFill>
                   <a:srgbClr val="261E38"/>
                 </a:solidFill>
-                <a:latin typeface="Outfit" pitchFamily="34" charset="0"/>
-                <a:ea typeface="Outfit" pitchFamily="34" charset="-122"/>
-                <a:cs typeface="Outfit" pitchFamily="34" charset="-120"/>
+                <a:latin typeface="Times New Roman" pitchFamily="34" charset="0"/>
+                <a:ea typeface="Times New Roman" pitchFamily="34" charset="-122"/>
+                <a:cs typeface="Times New Roman" pitchFamily="34" charset="-120"/>
               </a:rPr>
               <a:t>Client Presentation Layer</a:t>
             </a:r>
@@ -4958,9 +4931,9 @@
                 <a:solidFill>
                   <a:srgbClr val="7C3AED"/>
                 </a:solidFill>
-                <a:latin typeface="Plus Jakarta Sans" pitchFamily="34" charset="0"/>
-                <a:ea typeface="Plus Jakarta Sans" pitchFamily="34" charset="-122"/>
-                <a:cs typeface="Plus Jakarta Sans" pitchFamily="34" charset="-120"/>
+                <a:latin typeface="Times New Roman" pitchFamily="34" charset="0"/>
+                <a:ea typeface="Times New Roman" pitchFamily="34" charset="-122"/>
+                <a:cs typeface="Times New Roman" pitchFamily="34" charset="-120"/>
               </a:rPr>
               <a:t>Vue 3 + Vite + TypeScript</a:t>
             </a:r>
@@ -5000,9 +4973,9 @@
                 <a:solidFill>
                   <a:srgbClr val="5F5377"/>
                 </a:solidFill>
-                <a:latin typeface="Plus Jakarta Sans" pitchFamily="34" charset="0"/>
-                <a:ea typeface="Plus Jakarta Sans" pitchFamily="34" charset="-122"/>
-                <a:cs typeface="Plus Jakarta Sans" pitchFamily="34" charset="-120"/>
+                <a:latin typeface="Times New Roman" pitchFamily="34" charset="0"/>
+                <a:ea typeface="Times New Roman" pitchFamily="34" charset="-122"/>
+                <a:cs typeface="Times New Roman" pitchFamily="34" charset="-120"/>
               </a:rPr>
               <a:t>Reactive UI state management via appStore.ts, optimistic tactile interactions, component modules, and typed API service clients.</a:t>
             </a:r>
@@ -5062,9 +5035,9 @@
                 <a:solidFill>
                   <a:srgbClr val="9589B0"/>
                 </a:solidFill>
-                <a:latin typeface="Plus Jakarta Sans" pitchFamily="34" charset="0"/>
-                <a:ea typeface="Plus Jakarta Sans" pitchFamily="34" charset="-122"/>
-                <a:cs typeface="Plus Jakarta Sans" pitchFamily="34" charset="-120"/>
+                <a:latin typeface="Times New Roman" pitchFamily="34" charset="0"/>
+                <a:ea typeface="Times New Roman" pitchFamily="34" charset="-122"/>
+                <a:cs typeface="Times New Roman" pitchFamily="34" charset="-120"/>
               </a:rPr>
               <a:t>CORE CAPABILITIES:</a:t>
             </a:r>
@@ -5104,9 +5077,9 @@
                 <a:solidFill>
                   <a:srgbClr val="261E38"/>
                 </a:solidFill>
-                <a:latin typeface="Plus Jakarta Sans" pitchFamily="34" charset="0"/>
-                <a:ea typeface="Plus Jakarta Sans" pitchFamily="34" charset="-122"/>
-                <a:cs typeface="Plus Jakarta Sans" pitchFamily="34" charset="-120"/>
+                <a:latin typeface="Times New Roman" pitchFamily="34" charset="0"/>
+                <a:ea typeface="Times New Roman" pitchFamily="34" charset="-122"/>
+                <a:cs typeface="Times New Roman" pitchFamily="34" charset="-120"/>
               </a:rPr>
               <a:t>• Typed HTTP Client (apiClient.ts)</a:t>
             </a:r>
@@ -5146,9 +5119,9 @@
                 <a:solidFill>
                   <a:srgbClr val="261E38"/>
                 </a:solidFill>
-                <a:latin typeface="Plus Jakarta Sans" pitchFamily="34" charset="0"/>
-                <a:ea typeface="Plus Jakarta Sans" pitchFamily="34" charset="-122"/>
-                <a:cs typeface="Plus Jakarta Sans" pitchFamily="34" charset="-120"/>
+                <a:latin typeface="Times New Roman" pitchFamily="34" charset="0"/>
+                <a:ea typeface="Times New Roman" pitchFamily="34" charset="-122"/>
+                <a:cs typeface="Times New Roman" pitchFamily="34" charset="-120"/>
               </a:rPr>
               <a:t>• Optimistic UI state dispatch</a:t>
             </a:r>
@@ -5188,9 +5161,9 @@
                 <a:solidFill>
                   <a:srgbClr val="261E38"/>
                 </a:solidFill>
-                <a:latin typeface="Plus Jakarta Sans" pitchFamily="34" charset="0"/>
-                <a:ea typeface="Plus Jakarta Sans" pitchFamily="34" charset="-122"/>
-                <a:cs typeface="Plus Jakarta Sans" pitchFamily="34" charset="-120"/>
+                <a:latin typeface="Times New Roman" pitchFamily="34" charset="0"/>
+                <a:ea typeface="Times New Roman" pitchFamily="34" charset="-122"/>
+                <a:cs typeface="Times New Roman" pitchFamily="34" charset="-120"/>
               </a:rPr>
               <a:t>• Bearer Token session persistence</a:t>
             </a:r>
@@ -5230,9 +5203,9 @@
                 <a:solidFill>
                   <a:srgbClr val="261E38"/>
                 </a:solidFill>
-                <a:latin typeface="Plus Jakarta Sans" pitchFamily="34" charset="0"/>
-                <a:ea typeface="Plus Jakarta Sans" pitchFamily="34" charset="-122"/>
-                <a:cs typeface="Plus Jakarta Sans" pitchFamily="34" charset="-120"/>
+                <a:latin typeface="Times New Roman" pitchFamily="34" charset="0"/>
+                <a:ea typeface="Times New Roman" pitchFamily="34" charset="-122"/>
+                <a:cs typeface="Times New Roman" pitchFamily="34" charset="-120"/>
               </a:rPr>
               <a:t>• Vite Dev Proxy (/api -&gt; :3000)</a:t>
             </a:r>
@@ -5319,9 +5292,9 @@
                 <a:solidFill>
                   <a:srgbClr val="7C3AED"/>
                 </a:solidFill>
-                <a:latin typeface="Plus Jakarta Sans" pitchFamily="34" charset="0"/>
-                <a:ea typeface="Plus Jakarta Sans" pitchFamily="34" charset="-122"/>
-                <a:cs typeface="Plus Jakarta Sans" pitchFamily="34" charset="-120"/>
+                <a:latin typeface="Times New Roman" pitchFamily="34" charset="0"/>
+                <a:ea typeface="Times New Roman" pitchFamily="34" charset="-122"/>
+                <a:cs typeface="Times New Roman" pitchFamily="34" charset="-120"/>
               </a:rPr>
               <a:t>TIER 2</a:t>
             </a:r>
@@ -5358,9 +5331,9 @@
                 <a:solidFill>
                   <a:srgbClr val="261E38"/>
                 </a:solidFill>
-                <a:latin typeface="Outfit" pitchFamily="34" charset="0"/>
-                <a:ea typeface="Outfit" pitchFamily="34" charset="-122"/>
-                <a:cs typeface="Outfit" pitchFamily="34" charset="-120"/>
+                <a:latin typeface="Times New Roman" pitchFamily="34" charset="0"/>
+                <a:ea typeface="Times New Roman" pitchFamily="34" charset="-122"/>
+                <a:cs typeface="Times New Roman" pitchFamily="34" charset="-120"/>
               </a:rPr>
               <a:t>REST Gateway &amp; Engine</a:t>
             </a:r>
@@ -5397,9 +5370,9 @@
                 <a:solidFill>
                   <a:srgbClr val="7C3AED"/>
                 </a:solidFill>
-                <a:latin typeface="Plus Jakarta Sans" pitchFamily="34" charset="0"/>
-                <a:ea typeface="Plus Jakarta Sans" pitchFamily="34" charset="-122"/>
-                <a:cs typeface="Plus Jakarta Sans" pitchFamily="34" charset="-120"/>
+                <a:latin typeface="Times New Roman" pitchFamily="34" charset="0"/>
+                <a:ea typeface="Times New Roman" pitchFamily="34" charset="-122"/>
+                <a:cs typeface="Times New Roman" pitchFamily="34" charset="-120"/>
               </a:rPr>
               <a:t>Next.js 16 App Router</a:t>
             </a:r>
@@ -5439,9 +5412,9 @@
                 <a:solidFill>
                   <a:srgbClr val="5F5377"/>
                 </a:solidFill>
-                <a:latin typeface="Plus Jakarta Sans" pitchFamily="34" charset="0"/>
-                <a:ea typeface="Plus Jakarta Sans" pitchFamily="34" charset="-122"/>
-                <a:cs typeface="Plus Jakarta Sans" pitchFamily="34" charset="-120"/>
+                <a:latin typeface="Times New Roman" pitchFamily="34" charset="0"/>
+                <a:ea typeface="Times New Roman" pitchFamily="34" charset="-122"/>
+                <a:cs typeface="Times New Roman" pitchFamily="34" charset="-120"/>
               </a:rPr>
               <a:t>Serverless REST Route Handlers under /src/app/api with strict Zod schema validation, CORS headers, and standard JSON envelopes.</a:t>
             </a:r>
@@ -5501,9 +5474,9 @@
                 <a:solidFill>
                   <a:srgbClr val="9589B0"/>
                 </a:solidFill>
-                <a:latin typeface="Plus Jakarta Sans" pitchFamily="34" charset="0"/>
-                <a:ea typeface="Plus Jakarta Sans" pitchFamily="34" charset="-122"/>
-                <a:cs typeface="Plus Jakarta Sans" pitchFamily="34" charset="-120"/>
+                <a:latin typeface="Times New Roman" pitchFamily="34" charset="0"/>
+                <a:ea typeface="Times New Roman" pitchFamily="34" charset="-122"/>
+                <a:cs typeface="Times New Roman" pitchFamily="34" charset="-120"/>
               </a:rPr>
               <a:t>CORE CAPABILITIES:</a:t>
             </a:r>
@@ -5543,9 +5516,9 @@
                 <a:solidFill>
                   <a:srgbClr val="261E38"/>
                 </a:solidFill>
-                <a:latin typeface="Plus Jakarta Sans" pitchFamily="34" charset="0"/>
-                <a:ea typeface="Plus Jakarta Sans" pitchFamily="34" charset="-122"/>
-                <a:cs typeface="Plus Jakarta Sans" pitchFamily="34" charset="-120"/>
+                <a:latin typeface="Times New Roman" pitchFamily="34" charset="0"/>
+                <a:ea typeface="Times New Roman" pitchFamily="34" charset="-122"/>
+                <a:cs typeface="Times New Roman" pitchFamily="34" charset="-120"/>
               </a:rPr>
               <a:t>• Zod schema payload validation</a:t>
             </a:r>
@@ -5585,9 +5558,9 @@
                 <a:solidFill>
                   <a:srgbClr val="261E38"/>
                 </a:solidFill>
-                <a:latin typeface="Plus Jakarta Sans" pitchFamily="34" charset="0"/>
-                <a:ea typeface="Plus Jakarta Sans" pitchFamily="34" charset="-122"/>
-                <a:cs typeface="Plus Jakarta Sans" pitchFamily="34" charset="-120"/>
+                <a:latin typeface="Times New Roman" pitchFamily="34" charset="0"/>
+                <a:ea typeface="Times New Roman" pitchFamily="34" charset="-122"/>
+                <a:cs typeface="Times New Roman" pitchFamily="34" charset="-120"/>
               </a:rPr>
               <a:t>• Standard { success, data, error } envelopes</a:t>
             </a:r>
@@ -5627,9 +5600,9 @@
                 <a:solidFill>
                   <a:srgbClr val="261E38"/>
                 </a:solidFill>
-                <a:latin typeface="Plus Jakarta Sans" pitchFamily="34" charset="0"/>
-                <a:ea typeface="Plus Jakarta Sans" pitchFamily="34" charset="-122"/>
-                <a:cs typeface="Plus Jakarta Sans" pitchFamily="34" charset="-120"/>
+                <a:latin typeface="Times New Roman" pitchFamily="34" charset="0"/>
+                <a:ea typeface="Times New Roman" pitchFamily="34" charset="-122"/>
+                <a:cs typeface="Times New Roman" pitchFamily="34" charset="-120"/>
               </a:rPr>
               <a:t>• Supabase Auth session verification</a:t>
             </a:r>
@@ -5669,9 +5642,9 @@
                 <a:solidFill>
                   <a:srgbClr val="261E38"/>
                 </a:solidFill>
-                <a:latin typeface="Plus Jakarta Sans" pitchFamily="34" charset="0"/>
-                <a:ea typeface="Plus Jakarta Sans" pitchFamily="34" charset="-122"/>
-                <a:cs typeface="Plus Jakarta Sans" pitchFamily="34" charset="-120"/>
+                <a:latin typeface="Times New Roman" pitchFamily="34" charset="0"/>
+                <a:ea typeface="Times New Roman" pitchFamily="34" charset="-122"/>
+                <a:cs typeface="Times New Roman" pitchFamily="34" charset="-120"/>
               </a:rPr>
               <a:t>• Bilingual AI Triage processing</a:t>
             </a:r>
@@ -5758,9 +5731,9 @@
                 <a:solidFill>
                   <a:srgbClr val="0369A1"/>
                 </a:solidFill>
-                <a:latin typeface="Plus Jakarta Sans" pitchFamily="34" charset="0"/>
-                <a:ea typeface="Plus Jakarta Sans" pitchFamily="34" charset="-122"/>
-                <a:cs typeface="Plus Jakarta Sans" pitchFamily="34" charset="-120"/>
+                <a:latin typeface="Times New Roman" pitchFamily="34" charset="0"/>
+                <a:ea typeface="Times New Roman" pitchFamily="34" charset="-122"/>
+                <a:cs typeface="Times New Roman" pitchFamily="34" charset="-120"/>
               </a:rPr>
               <a:t>TIER 3</a:t>
             </a:r>
@@ -5797,9 +5770,9 @@
                 <a:solidFill>
                   <a:srgbClr val="261E38"/>
                 </a:solidFill>
-                <a:latin typeface="Outfit" pitchFamily="34" charset="0"/>
-                <a:ea typeface="Outfit" pitchFamily="34" charset="-122"/>
-                <a:cs typeface="Outfit" pitchFamily="34" charset="-120"/>
+                <a:latin typeface="Times New Roman" pitchFamily="34" charset="0"/>
+                <a:ea typeface="Times New Roman" pitchFamily="34" charset="-122"/>
+                <a:cs typeface="Times New Roman" pitchFamily="34" charset="-120"/>
               </a:rPr>
               <a:t>Cloud Persistence &amp; Auth</a:t>
             </a:r>
@@ -5836,9 +5809,9 @@
                 <a:solidFill>
                   <a:srgbClr val="7C3AED"/>
                 </a:solidFill>
-                <a:latin typeface="Plus Jakarta Sans" pitchFamily="34" charset="0"/>
-                <a:ea typeface="Plus Jakarta Sans" pitchFamily="34" charset="-122"/>
-                <a:cs typeface="Plus Jakarta Sans" pitchFamily="34" charset="-120"/>
+                <a:latin typeface="Times New Roman" pitchFamily="34" charset="0"/>
+                <a:ea typeface="Times New Roman" pitchFamily="34" charset="-122"/>
+                <a:cs typeface="Times New Roman" pitchFamily="34" charset="-120"/>
               </a:rPr>
               <a:t>Prisma 7 + PostgreSQL</a:t>
             </a:r>
@@ -5878,9 +5851,9 @@
                 <a:solidFill>
                   <a:srgbClr val="5F5377"/>
                 </a:solidFill>
-                <a:latin typeface="Plus Jakarta Sans" pitchFamily="34" charset="0"/>
-                <a:ea typeface="Plus Jakarta Sans" pitchFamily="34" charset="-122"/>
-                <a:cs typeface="Plus Jakarta Sans" pitchFamily="34" charset="-120"/>
+                <a:latin typeface="Times New Roman" pitchFamily="34" charset="0"/>
+                <a:ea typeface="Times New Roman" pitchFamily="34" charset="-122"/>
+                <a:cs typeface="Times New Roman" pitchFamily="34" charset="-120"/>
               </a:rPr>
               <a:t>Cloud database hosted on Supabase with 18 synchronized data models, Transaction/Session poolers, and secure JWT auth engine.</a:t>
             </a:r>
@@ -5940,9 +5913,9 @@
                 <a:solidFill>
                   <a:srgbClr val="9589B0"/>
                 </a:solidFill>
-                <a:latin typeface="Plus Jakarta Sans" pitchFamily="34" charset="0"/>
-                <a:ea typeface="Plus Jakarta Sans" pitchFamily="34" charset="-122"/>
-                <a:cs typeface="Plus Jakarta Sans" pitchFamily="34" charset="-120"/>
+                <a:latin typeface="Times New Roman" pitchFamily="34" charset="0"/>
+                <a:ea typeface="Times New Roman" pitchFamily="34" charset="-122"/>
+                <a:cs typeface="Times New Roman" pitchFamily="34" charset="-120"/>
               </a:rPr>
               <a:t>CORE CAPABILITIES:</a:t>
             </a:r>
@@ -5982,9 +5955,9 @@
                 <a:solidFill>
                   <a:srgbClr val="261E38"/>
                 </a:solidFill>
-                <a:latin typeface="Plus Jakarta Sans" pitchFamily="34" charset="0"/>
-                <a:ea typeface="Plus Jakarta Sans" pitchFamily="34" charset="-122"/>
-                <a:cs typeface="Plus Jakarta Sans" pitchFamily="34" charset="-120"/>
+                <a:latin typeface="Times New Roman" pitchFamily="34" charset="0"/>
+                <a:ea typeface="Times New Roman" pitchFamily="34" charset="-122"/>
+                <a:cs typeface="Times New Roman" pitchFamily="34" charset="-120"/>
               </a:rPr>
               <a:t>• 18 relational schema models</a:t>
             </a:r>
@@ -6024,9 +5997,9 @@
                 <a:solidFill>
                   <a:srgbClr val="261E38"/>
                 </a:solidFill>
-                <a:latin typeface="Plus Jakarta Sans" pitchFamily="34" charset="0"/>
-                <a:ea typeface="Plus Jakarta Sans" pitchFamily="34" charset="-122"/>
-                <a:cs typeface="Plus Jakarta Sans" pitchFamily="34" charset="-120"/>
+                <a:latin typeface="Times New Roman" pitchFamily="34" charset="0"/>
+                <a:ea typeface="Times New Roman" pitchFamily="34" charset="-122"/>
+                <a:cs typeface="Times New Roman" pitchFamily="34" charset="-120"/>
               </a:rPr>
               <a:t>• Supabase Transaction Pooler (Port 6543)</a:t>
             </a:r>
@@ -6066,9 +6039,9 @@
                 <a:solidFill>
                   <a:srgbClr val="261E38"/>
                 </a:solidFill>
-                <a:latin typeface="Plus Jakarta Sans" pitchFamily="34" charset="0"/>
-                <a:ea typeface="Plus Jakarta Sans" pitchFamily="34" charset="-122"/>
-                <a:cs typeface="Plus Jakarta Sans" pitchFamily="34" charset="-120"/>
+                <a:latin typeface="Times New Roman" pitchFamily="34" charset="0"/>
+                <a:ea typeface="Times New Roman" pitchFamily="34" charset="-122"/>
+                <a:cs typeface="Times New Roman" pitchFamily="34" charset="-120"/>
               </a:rPr>
               <a:t>• Session Pooler for migrations (Port 5432)</a:t>
             </a:r>
@@ -6108,9 +6081,9 @@
                 <a:solidFill>
                   <a:srgbClr val="261E38"/>
                 </a:solidFill>
-                <a:latin typeface="Plus Jakarta Sans" pitchFamily="34" charset="0"/>
-                <a:ea typeface="Plus Jakarta Sans" pitchFamily="34" charset="-122"/>
-                <a:cs typeface="Plus Jakarta Sans" pitchFamily="34" charset="-120"/>
+                <a:latin typeface="Times New Roman" pitchFamily="34" charset="0"/>
+                <a:ea typeface="Times New Roman" pitchFamily="34" charset="-122"/>
+                <a:cs typeface="Times New Roman" pitchFamily="34" charset="-120"/>
               </a:rPr>
               <a:t>• PostgreSQL Row Level Security (RLS)</a:t>
             </a:r>
@@ -6204,9 +6177,9 @@
                 <a:solidFill>
                   <a:srgbClr val="7C3AED"/>
                 </a:solidFill>
-                <a:latin typeface="Outfit" pitchFamily="34" charset="0"/>
-                <a:ea typeface="Outfit" pitchFamily="34" charset="-122"/>
-                <a:cs typeface="Outfit" pitchFamily="34" charset="-120"/>
+                <a:latin typeface="Times New Roman" pitchFamily="34" charset="0"/>
+                <a:ea typeface="Times New Roman" pitchFamily="34" charset="-122"/>
+                <a:cs typeface="Times New Roman" pitchFamily="34" charset="-120"/>
               </a:rPr>
               <a:t>🐾 Nuzzle Engine</a:t>
             </a:r>
@@ -6243,9 +6216,9 @@
                 <a:solidFill>
                   <a:srgbClr val="5F5377"/>
                 </a:solidFill>
-                <a:latin typeface="Plus Jakarta Sans" pitchFamily="34" charset="0"/>
-                <a:ea typeface="Plus Jakarta Sans" pitchFamily="34" charset="-122"/>
-                <a:cs typeface="Plus Jakarta Sans" pitchFamily="34" charset="-120"/>
+                <a:latin typeface="Times New Roman" pitchFamily="34" charset="0"/>
+                <a:ea typeface="Times New Roman" pitchFamily="34" charset="-122"/>
+                <a:cs typeface="Times New Roman" pitchFamily="34" charset="-120"/>
               </a:rPr>
               <a:t>Slide 3 / 10 • Full-Stack REST API Architecture</a:t>
             </a:r>
@@ -6282,9 +6255,9 @@
                 <a:solidFill>
                   <a:srgbClr val="7C3AED"/>
                 </a:solidFill>
-                <a:latin typeface="Plus Jakarta Sans" pitchFamily="34" charset="0"/>
-                <a:ea typeface="Plus Jakarta Sans" pitchFamily="34" charset="-122"/>
-                <a:cs typeface="Plus Jakarta Sans" pitchFamily="34" charset="-120"/>
+                <a:latin typeface="Times New Roman" pitchFamily="34" charset="0"/>
+                <a:ea typeface="Times New Roman" pitchFamily="34" charset="-122"/>
+                <a:cs typeface="Times New Roman" pitchFamily="34" charset="-120"/>
               </a:rPr>
               <a:t>SECURITY &amp; IDENTITY LAYER</a:t>
             </a:r>
@@ -6321,9 +6294,9 @@
                 <a:solidFill>
                   <a:srgbClr val="261E38"/>
                 </a:solidFill>
-                <a:latin typeface="Outfit" pitchFamily="34" charset="0"/>
-                <a:ea typeface="Outfit" pitchFamily="34" charset="-122"/>
-                <a:cs typeface="Outfit" pitchFamily="34" charset="-120"/>
+                <a:latin typeface="Times New Roman" pitchFamily="34" charset="0"/>
+                <a:ea typeface="Times New Roman" pitchFamily="34" charset="-122"/>
+                <a:cs typeface="Times New Roman" pitchFamily="34" charset="-120"/>
               </a:rPr>
               <a:t>Multi-Role Authentication &amp; Supabase JWT Lifecycle</a:t>
             </a:r>
@@ -6383,9 +6356,9 @@
                 <a:solidFill>
                   <a:srgbClr val="9589B0"/>
                 </a:solidFill>
-                <a:latin typeface="Plus Jakarta Sans" pitchFamily="34" charset="0"/>
-                <a:ea typeface="Plus Jakarta Sans" pitchFamily="34" charset="-122"/>
-                <a:cs typeface="Plus Jakarta Sans" pitchFamily="34" charset="-120"/>
+                <a:latin typeface="Times New Roman" pitchFamily="34" charset="0"/>
+                <a:ea typeface="Times New Roman" pitchFamily="34" charset="-122"/>
+                <a:cs typeface="Times New Roman" pitchFamily="34" charset="-120"/>
               </a:rPr>
               <a:t>Nuzzle API v2.0 • Abu Zafor, Nadim Rahman, Rizvi Sarker • Technopreneurship 2026</a:t>
             </a:r>
@@ -6447,9 +6420,9 @@
                 <a:solidFill>
                   <a:srgbClr val="7C3AED"/>
                 </a:solidFill>
-                <a:latin typeface="Plus Jakarta Sans" pitchFamily="34" charset="0"/>
-                <a:ea typeface="Plus Jakarta Sans" pitchFamily="34" charset="-122"/>
-                <a:cs typeface="Plus Jakarta Sans" pitchFamily="34" charset="-120"/>
+                <a:latin typeface="Times New Roman" pitchFamily="34" charset="0"/>
+                <a:ea typeface="Times New Roman" pitchFamily="34" charset="-122"/>
+                <a:cs typeface="Times New Roman" pitchFamily="34" charset="-120"/>
               </a:rPr>
               <a:t>3-ROLE HIERARCHY &amp; PERMISSIONS</a:t>
             </a:r>
@@ -6511,9 +6484,9 @@
                 <a:solidFill>
                   <a:srgbClr val="261E38"/>
                 </a:solidFill>
-                <a:latin typeface="Outfit" pitchFamily="34" charset="0"/>
-                <a:ea typeface="Outfit" pitchFamily="34" charset="-122"/>
-                <a:cs typeface="Outfit" pitchFamily="34" charset="-120"/>
+                <a:latin typeface="Times New Roman" pitchFamily="34" charset="0"/>
+                <a:ea typeface="Times New Roman" pitchFamily="34" charset="-122"/>
+                <a:cs typeface="Times New Roman" pitchFamily="34" charset="-120"/>
               </a:rPr>
               <a:t>🐾 Pet Parent</a:t>
             </a:r>
@@ -6550,9 +6523,9 @@
                 <a:solidFill>
                   <a:srgbClr val="5F5377"/>
                 </a:solidFill>
-                <a:latin typeface="Plus Jakarta Sans" pitchFamily="34" charset="0"/>
-                <a:ea typeface="Plus Jakarta Sans" pitchFamily="34" charset="-122"/>
-                <a:cs typeface="Plus Jakarta Sans" pitchFamily="34" charset="-120"/>
+                <a:latin typeface="Times New Roman" pitchFamily="34" charset="0"/>
+                <a:ea typeface="Times New Roman" pitchFamily="34" charset="-122"/>
+                <a:cs typeface="Times New Roman" pitchFamily="34" charset="-120"/>
               </a:rPr>
               <a:t>Guardian Passports, Den Feed, Lost Pet Alerts, Vet Booking</a:t>
             </a:r>
@@ -6614,9 +6587,9 @@
                 <a:solidFill>
                   <a:srgbClr val="261E38"/>
                 </a:solidFill>
-                <a:latin typeface="Outfit" pitchFamily="34" charset="0"/>
-                <a:ea typeface="Outfit" pitchFamily="34" charset="-122"/>
-                <a:cs typeface="Outfit" pitchFamily="34" charset="-120"/>
+                <a:latin typeface="Times New Roman" pitchFamily="34" charset="0"/>
+                <a:ea typeface="Times New Roman" pitchFamily="34" charset="-122"/>
+                <a:cs typeface="Times New Roman" pitchFamily="34" charset="-120"/>
               </a:rPr>
               <a:t>🛍️ Verified Pet Store</a:t>
             </a:r>
@@ -6653,9 +6626,9 @@
                 <a:solidFill>
                   <a:srgbClr val="5F5377"/>
                 </a:solidFill>
-                <a:latin typeface="Plus Jakarta Sans" pitchFamily="34" charset="0"/>
-                <a:ea typeface="Plus Jakarta Sans" pitchFamily="34" charset="-122"/>
-                <a:cs typeface="Plus Jakarta Sans" pitchFamily="34" charset="-120"/>
+                <a:latin typeface="Times New Roman" pitchFamily="34" charset="0"/>
+                <a:ea typeface="Times New Roman" pitchFamily="34" charset="-122"/>
+                <a:cs typeface="Times New Roman" pitchFamily="34" charset="-120"/>
               </a:rPr>
               <a:t>Boutique Catalog, Order Management, Gold Shield Badge</a:t>
             </a:r>
@@ -6717,9 +6690,9 @@
                 <a:solidFill>
                   <a:srgbClr val="261E38"/>
                 </a:solidFill>
-                <a:latin typeface="Outfit" pitchFamily="34" charset="0"/>
-                <a:ea typeface="Outfit" pitchFamily="34" charset="-122"/>
-                <a:cs typeface="Outfit" pitchFamily="34" charset="-120"/>
+                <a:latin typeface="Times New Roman" pitchFamily="34" charset="0"/>
+                <a:ea typeface="Times New Roman" pitchFamily="34" charset="-122"/>
+                <a:cs typeface="Times New Roman" pitchFamily="34" charset="-120"/>
               </a:rPr>
               <a:t>🏥 Vet Clinic / Hospital</a:t>
             </a:r>
@@ -6756,9 +6729,9 @@
                 <a:solidFill>
                   <a:srgbClr val="5F5377"/>
                 </a:solidFill>
-                <a:latin typeface="Plus Jakarta Sans" pitchFamily="34" charset="0"/>
-                <a:ea typeface="Plus Jakarta Sans" pitchFamily="34" charset="-122"/>
-                <a:cs typeface="Plus Jakarta Sans" pitchFamily="34" charset="-120"/>
+                <a:latin typeface="Times New Roman" pitchFamily="34" charset="0"/>
+                <a:ea typeface="Times New Roman" pitchFamily="34" charset="-122"/>
+                <a:cs typeface="Times New Roman" pitchFamily="34" charset="-120"/>
               </a:rPr>
               <a:t>Telemedicine Slot Management, PawDoctor Triage Partner</a:t>
             </a:r>
@@ -6798,9 +6771,9 @@
                 <a:solidFill>
                   <a:srgbClr val="5F5377"/>
                 </a:solidFill>
-                <a:latin typeface="Plus Jakarta Sans" pitchFamily="34" charset="0"/>
-                <a:ea typeface="Plus Jakarta Sans" pitchFamily="34" charset="-122"/>
-                <a:cs typeface="Plus Jakarta Sans" pitchFamily="34" charset="-120"/>
+                <a:latin typeface="Times New Roman" pitchFamily="34" charset="0"/>
+                <a:ea typeface="Times New Roman" pitchFamily="34" charset="-122"/>
+                <a:cs typeface="Times New Roman" pitchFamily="34" charset="-120"/>
               </a:rPr>
               <a:t>Session Token Protocol: Bearer JWT stored in localStorage and automatically forwarded via apiClient.ts Request Interceptors with 401 token refresh.</a:t>
             </a:r>
@@ -6862,9 +6835,9 @@
                 <a:solidFill>
                   <a:srgbClr val="947DEE"/>
                 </a:solidFill>
-                <a:latin typeface="Plus Jakarta Sans" pitchFamily="34" charset="0"/>
-                <a:ea typeface="Plus Jakarta Sans" pitchFamily="34" charset="-122"/>
-                <a:cs typeface="Plus Jakarta Sans" pitchFamily="34" charset="-120"/>
+                <a:latin typeface="Times New Roman" pitchFamily="34" charset="0"/>
+                <a:ea typeface="Times New Roman" pitchFamily="34" charset="-122"/>
+                <a:cs typeface="Times New Roman" pitchFamily="34" charset="-120"/>
               </a:rPr>
               <a:t>AUTHENTICATION REST HANDLERS</a:t>
             </a:r>
@@ -6926,9 +6899,9 @@
                 <a:solidFill>
                   <a:srgbClr val="10B981"/>
                 </a:solidFill>
-                <a:latin typeface="Outfit" pitchFamily="34" charset="0"/>
-                <a:ea typeface="Outfit" pitchFamily="34" charset="-122"/>
-                <a:cs typeface="Outfit" pitchFamily="34" charset="-120"/>
+                <a:latin typeface="Times New Roman" pitchFamily="34" charset="0"/>
+                <a:ea typeface="Times New Roman" pitchFamily="34" charset="-122"/>
+                <a:cs typeface="Times New Roman" pitchFamily="34" charset="-120"/>
               </a:rPr>
               <a:t>POST</a:t>
             </a:r>
@@ -7007,9 +6980,9 @@
                 <a:solidFill>
                   <a:srgbClr val="9589B0"/>
                 </a:solidFill>
-                <a:latin typeface="Plus Jakarta Sans" pitchFamily="34" charset="0"/>
-                <a:ea typeface="Plus Jakarta Sans" pitchFamily="34" charset="-122"/>
-                <a:cs typeface="Plus Jakarta Sans" pitchFamily="34" charset="-120"/>
+                <a:latin typeface="Times New Roman" pitchFamily="34" charset="0"/>
+                <a:ea typeface="Times New Roman" pitchFamily="34" charset="-122"/>
+                <a:cs typeface="Times New Roman" pitchFamily="34" charset="-120"/>
               </a:rPr>
               <a:t>Registers in Supabase Auth &amp; creates linked PostgreSQL Owner</a:t>
             </a:r>
@@ -7071,9 +7044,9 @@
                 <a:solidFill>
                   <a:srgbClr val="10B981"/>
                 </a:solidFill>
-                <a:latin typeface="Outfit" pitchFamily="34" charset="0"/>
-                <a:ea typeface="Outfit" pitchFamily="34" charset="-122"/>
-                <a:cs typeface="Outfit" pitchFamily="34" charset="-120"/>
+                <a:latin typeface="Times New Roman" pitchFamily="34" charset="0"/>
+                <a:ea typeface="Times New Roman" pitchFamily="34" charset="-122"/>
+                <a:cs typeface="Times New Roman" pitchFamily="34" charset="-120"/>
               </a:rPr>
               <a:t>POST</a:t>
             </a:r>
@@ -7152,9 +7125,9 @@
                 <a:solidFill>
                   <a:srgbClr val="9589B0"/>
                 </a:solidFill>
-                <a:latin typeface="Plus Jakarta Sans" pitchFamily="34" charset="0"/>
-                <a:ea typeface="Plus Jakarta Sans" pitchFamily="34" charset="-122"/>
-                <a:cs typeface="Plus Jakarta Sans" pitchFamily="34" charset="-120"/>
+                <a:latin typeface="Times New Roman" pitchFamily="34" charset="0"/>
+                <a:ea typeface="Times New Roman" pitchFamily="34" charset="-122"/>
+                <a:cs typeface="Times New Roman" pitchFamily="34" charset="-120"/>
               </a:rPr>
               <a:t>Verifies credentials via Supabase with fallback role switch</a:t>
             </a:r>
@@ -7216,9 +7189,9 @@
                 <a:solidFill>
                   <a:srgbClr val="10B981"/>
                 </a:solidFill>
-                <a:latin typeface="Outfit" pitchFamily="34" charset="0"/>
-                <a:ea typeface="Outfit" pitchFamily="34" charset="-122"/>
-                <a:cs typeface="Outfit" pitchFamily="34" charset="-120"/>
+                <a:latin typeface="Times New Roman" pitchFamily="34" charset="0"/>
+                <a:ea typeface="Times New Roman" pitchFamily="34" charset="-122"/>
+                <a:cs typeface="Times New Roman" pitchFamily="34" charset="-120"/>
               </a:rPr>
               <a:t>GET</a:t>
             </a:r>
@@ -7297,9 +7270,9 @@
                 <a:solidFill>
                   <a:srgbClr val="9589B0"/>
                 </a:solidFill>
-                <a:latin typeface="Plus Jakarta Sans" pitchFamily="34" charset="0"/>
-                <a:ea typeface="Plus Jakarta Sans" pitchFamily="34" charset="-122"/>
-                <a:cs typeface="Plus Jakarta Sans" pitchFamily="34" charset="-120"/>
+                <a:latin typeface="Times New Roman" pitchFamily="34" charset="0"/>
+                <a:ea typeface="Times New Roman" pitchFamily="34" charset="-122"/>
+                <a:cs typeface="Times New Roman" pitchFamily="34" charset="-120"/>
               </a:rPr>
               <a:t>Validates Bearer token &amp; returns Owner with pet passports</a:t>
             </a:r>
@@ -7393,9 +7366,9 @@
                 <a:solidFill>
                   <a:srgbClr val="7C3AED"/>
                 </a:solidFill>
-                <a:latin typeface="Outfit" pitchFamily="34" charset="0"/>
-                <a:ea typeface="Outfit" pitchFamily="34" charset="-122"/>
-                <a:cs typeface="Outfit" pitchFamily="34" charset="-120"/>
+                <a:latin typeface="Times New Roman" pitchFamily="34" charset="0"/>
+                <a:ea typeface="Times New Roman" pitchFamily="34" charset="-122"/>
+                <a:cs typeface="Times New Roman" pitchFamily="34" charset="-120"/>
               </a:rPr>
               <a:t>🐾 Nuzzle Engine</a:t>
             </a:r>
@@ -7432,9 +7405,9 @@
                 <a:solidFill>
                   <a:srgbClr val="5F5377"/>
                 </a:solidFill>
-                <a:latin typeface="Plus Jakarta Sans" pitchFamily="34" charset="0"/>
-                <a:ea typeface="Plus Jakarta Sans" pitchFamily="34" charset="-122"/>
-                <a:cs typeface="Plus Jakarta Sans" pitchFamily="34" charset="-120"/>
+                <a:latin typeface="Times New Roman" pitchFamily="34" charset="0"/>
+                <a:ea typeface="Times New Roman" pitchFamily="34" charset="-122"/>
+                <a:cs typeface="Times New Roman" pitchFamily="34" charset="-120"/>
               </a:rPr>
               <a:t>Slide 4 / 10 • Full-Stack REST API Architecture</a:t>
             </a:r>
@@ -7471,9 +7444,9 @@
                 <a:solidFill>
                   <a:srgbClr val="7C3AED"/>
                 </a:solidFill>
-                <a:latin typeface="Plus Jakarta Sans" pitchFamily="34" charset="0"/>
-                <a:ea typeface="Plus Jakarta Sans" pitchFamily="34" charset="-122"/>
-                <a:cs typeface="Plus Jakarta Sans" pitchFamily="34" charset="-120"/>
+                <a:latin typeface="Times New Roman" pitchFamily="34" charset="0"/>
+                <a:ea typeface="Times New Roman" pitchFamily="34" charset="-122"/>
+                <a:cs typeface="Times New Roman" pitchFamily="34" charset="-120"/>
               </a:rPr>
               <a:t>SOCIAL ENGAGEMENT ENGINE</a:t>
             </a:r>
@@ -7510,9 +7483,9 @@
                 <a:solidFill>
                   <a:srgbClr val="261E38"/>
                 </a:solidFill>
-                <a:latin typeface="Outfit" pitchFamily="34" charset="0"/>
-                <a:ea typeface="Outfit" pitchFamily="34" charset="-122"/>
-                <a:cs typeface="Outfit" pitchFamily="34" charset="-120"/>
+                <a:latin typeface="Times New Roman" pitchFamily="34" charset="0"/>
+                <a:ea typeface="Times New Roman" pitchFamily="34" charset="-122"/>
+                <a:cs typeface="Times New Roman" pitchFamily="34" charset="-120"/>
               </a:rPr>
               <a:t>Den Feed, Tactile Reactions &amp; 24h Stories API</a:t>
             </a:r>
@@ -7572,9 +7545,9 @@
                 <a:solidFill>
                   <a:srgbClr val="9589B0"/>
                 </a:solidFill>
-                <a:latin typeface="Plus Jakarta Sans" pitchFamily="34" charset="0"/>
-                <a:ea typeface="Plus Jakarta Sans" pitchFamily="34" charset="-122"/>
-                <a:cs typeface="Plus Jakarta Sans" pitchFamily="34" charset="-120"/>
+                <a:latin typeface="Times New Roman" pitchFamily="34" charset="0"/>
+                <a:ea typeface="Times New Roman" pitchFamily="34" charset="-122"/>
+                <a:cs typeface="Times New Roman" pitchFamily="34" charset="-120"/>
               </a:rPr>
               <a:t>Nuzzle API v2.0 • Abu Zafor, Nadim Rahman, Rizvi Sarker • Technopreneurship 2026</a:t>
             </a:r>
@@ -7636,9 +7609,9 @@
                 <a:solidFill>
                   <a:srgbClr val="7C3AED"/>
                 </a:solidFill>
-                <a:latin typeface="Plus Jakarta Sans" pitchFamily="34" charset="0"/>
-                <a:ea typeface="Plus Jakarta Sans" pitchFamily="34" charset="-122"/>
-                <a:cs typeface="Plus Jakarta Sans" pitchFamily="34" charset="-120"/>
+                <a:latin typeface="Times New Roman" pitchFamily="34" charset="0"/>
+                <a:ea typeface="Times New Roman" pitchFamily="34" charset="-122"/>
+                <a:cs typeface="Times New Roman" pitchFamily="34" charset="-120"/>
               </a:rPr>
               <a:t>CORE FEED &amp; MOMENTS CAPABILITIES</a:t>
             </a:r>
@@ -7700,9 +7673,9 @@
                 <a:solidFill>
                   <a:srgbClr val="261E38"/>
                 </a:solidFill>
-                <a:latin typeface="Outfit" pitchFamily="34" charset="0"/>
-                <a:ea typeface="Outfit" pitchFamily="34" charset="-122"/>
-                <a:cs typeface="Outfit" pitchFamily="34" charset="-120"/>
+                <a:latin typeface="Times New Roman" pitchFamily="34" charset="0"/>
+                <a:ea typeface="Times New Roman" pitchFamily="34" charset="-122"/>
+                <a:cs typeface="Times New Roman" pitchFamily="34" charset="-120"/>
               </a:rPr>
               <a:t>Paginated Den Feed</a:t>
             </a:r>
@@ -7739,9 +7712,9 @@
                 <a:solidFill>
                   <a:srgbClr val="5F5377"/>
                 </a:solidFill>
-                <a:latin typeface="Plus Jakarta Sans" pitchFamily="34" charset="0"/>
-                <a:ea typeface="Plus Jakarta Sans" pitchFamily="34" charset="-122"/>
-                <a:cs typeface="Plus Jakarta Sans" pitchFamily="34" charset="-120"/>
+                <a:latin typeface="Times New Roman" pitchFamily="34" charset="0"/>
+                <a:ea typeface="Times New Roman" pitchFamily="34" charset="-122"/>
+                <a:cs typeface="Times New Roman" pitchFamily="34" charset="-120"/>
               </a:rPr>
               <a:t>GET /api/posts supports category filtering, hashtag lookup, and cursor pagination.</a:t>
             </a:r>
@@ -7803,9 +7776,9 @@
                 <a:solidFill>
                   <a:srgbClr val="261E38"/>
                 </a:solidFill>
-                <a:latin typeface="Outfit" pitchFamily="34" charset="0"/>
-                <a:ea typeface="Outfit" pitchFamily="34" charset="-122"/>
-                <a:cs typeface="Outfit" pitchFamily="34" charset="-120"/>
+                <a:latin typeface="Times New Roman" pitchFamily="34" charset="0"/>
+                <a:ea typeface="Times New Roman" pitchFamily="34" charset="-122"/>
+                <a:cs typeface="Times New Roman" pitchFamily="34" charset="-120"/>
               </a:rPr>
               <a:t>5 Tactile Pet Reactions</a:t>
             </a:r>
@@ -7842,9 +7815,9 @@
                 <a:solidFill>
                   <a:srgbClr val="5F5377"/>
                 </a:solidFill>
-                <a:latin typeface="Plus Jakarta Sans" pitchFamily="34" charset="0"/>
-                <a:ea typeface="Plus Jakarta Sans" pitchFamily="34" charset="-122"/>
-                <a:cs typeface="Plus Jakarta Sans" pitchFamily="34" charset="-120"/>
+                <a:latin typeface="Times New Roman" pitchFamily="34" charset="0"/>
+                <a:ea typeface="Times New Roman" pitchFamily="34" charset="-122"/>
+                <a:cs typeface="Times New Roman" pitchFamily="34" charset="-120"/>
               </a:rPr>
               <a:t>POST /api/posts/:id/react toggles Paw 🐾, Nuzzle 💜, Treat 🦴, Ball 🎾, and Purr 😻.</a:t>
             </a:r>
@@ -7906,9 +7879,9 @@
                 <a:solidFill>
                   <a:srgbClr val="261E38"/>
                 </a:solidFill>
-                <a:latin typeface="Outfit" pitchFamily="34" charset="0"/>
-                <a:ea typeface="Outfit" pitchFamily="34" charset="-122"/>
-                <a:cs typeface="Outfit" pitchFamily="34" charset="-120"/>
+                <a:latin typeface="Times New Roman" pitchFamily="34" charset="0"/>
+                <a:ea typeface="Times New Roman" pitchFamily="34" charset="-122"/>
+                <a:cs typeface="Times New Roman" pitchFamily="34" charset="-120"/>
               </a:rPr>
               <a:t>Pet Persona Comments</a:t>
             </a:r>
@@ -7945,9 +7918,9 @@
                 <a:solidFill>
                   <a:srgbClr val="5F5377"/>
                 </a:solidFill>
-                <a:latin typeface="Plus Jakarta Sans" pitchFamily="34" charset="0"/>
-                <a:ea typeface="Plus Jakarta Sans" pitchFamily="34" charset="-122"/>
-                <a:cs typeface="Plus Jakarta Sans" pitchFamily="34" charset="-120"/>
+                <a:latin typeface="Times New Roman" pitchFamily="34" charset="0"/>
+                <a:ea typeface="Times New Roman" pitchFamily="34" charset="-122"/>
+                <a:cs typeface="Times New Roman" pitchFamily="34" charset="-120"/>
               </a:rPr>
               <a:t>POST /api/posts/:id/comments supports posting as either human parent or as the pet.</a:t>
             </a:r>
@@ -8009,9 +7982,9 @@
                 <a:solidFill>
                   <a:srgbClr val="261E38"/>
                 </a:solidFill>
-                <a:latin typeface="Outfit" pitchFamily="34" charset="0"/>
-                <a:ea typeface="Outfit" pitchFamily="34" charset="-122"/>
-                <a:cs typeface="Outfit" pitchFamily="34" charset="-120"/>
+                <a:latin typeface="Times New Roman" pitchFamily="34" charset="0"/>
+                <a:ea typeface="Times New Roman" pitchFamily="34" charset="-122"/>
+                <a:cs typeface="Times New Roman" pitchFamily="34" charset="-120"/>
               </a:rPr>
               <a:t>Snuggle Circles (24h Stories)</a:t>
             </a:r>
@@ -8048,9 +8021,9 @@
                 <a:solidFill>
                   <a:srgbClr val="5F5377"/>
                 </a:solidFill>
-                <a:latin typeface="Plus Jakarta Sans" pitchFamily="34" charset="0"/>
-                <a:ea typeface="Plus Jakarta Sans" pitchFamily="34" charset="-122"/>
-                <a:cs typeface="Plus Jakarta Sans" pitchFamily="34" charset="-120"/>
+                <a:latin typeface="Times New Roman" pitchFamily="34" charset="0"/>
+                <a:ea typeface="Times New Roman" pitchFamily="34" charset="-122"/>
+                <a:cs typeface="Times New Roman" pitchFamily="34" charset="-120"/>
               </a:rPr>
               <a:t>GET /api/stories fetches ephemeral active video/photo segments created in last 24 hours.</a:t>
             </a:r>
@@ -8112,9 +8085,9 @@
                 <a:solidFill>
                   <a:srgbClr val="7C3AED"/>
                 </a:solidFill>
-                <a:latin typeface="Plus Jakarta Sans" pitchFamily="34" charset="0"/>
-                <a:ea typeface="Plus Jakarta Sans" pitchFamily="34" charset="-122"/>
-                <a:cs typeface="Plus Jakarta Sans" pitchFamily="34" charset="-120"/>
+                <a:latin typeface="Times New Roman" pitchFamily="34" charset="0"/>
+                <a:ea typeface="Times New Roman" pitchFamily="34" charset="-122"/>
+                <a:cs typeface="Times New Roman" pitchFamily="34" charset="-120"/>
               </a:rPr>
               <a:t>5 TACTILE PET REACTIONS</a:t>
             </a:r>
@@ -8212,9 +8185,9 @@
                 <a:solidFill>
                   <a:srgbClr val="261E38"/>
                 </a:solidFill>
-                <a:latin typeface="Outfit" pitchFamily="34" charset="0"/>
-                <a:ea typeface="Outfit" pitchFamily="34" charset="-122"/>
-                <a:cs typeface="Outfit" pitchFamily="34" charset="-120"/>
+                <a:latin typeface="Times New Roman" pitchFamily="34" charset="0"/>
+                <a:ea typeface="Times New Roman" pitchFamily="34" charset="-122"/>
+                <a:cs typeface="Times New Roman" pitchFamily="34" charset="-120"/>
               </a:rPr>
               <a:t>Paw Print</a:t>
             </a:r>
@@ -8251,9 +8224,9 @@
                 <a:solidFill>
                   <a:srgbClr val="5F5377"/>
                 </a:solidFill>
-                <a:latin typeface="Plus Jakarta Sans" pitchFamily="34" charset="0"/>
-                <a:ea typeface="Plus Jakarta Sans" pitchFamily="34" charset="-122"/>
-                <a:cs typeface="Plus Jakarta Sans" pitchFamily="34" charset="-120"/>
+                <a:latin typeface="Times New Roman" pitchFamily="34" charset="0"/>
+                <a:ea typeface="Times New Roman" pitchFamily="34" charset="-122"/>
+                <a:cs typeface="Times New Roman" pitchFamily="34" charset="-120"/>
               </a:rPr>
               <a:t>Standard appreciation</a:t>
             </a:r>
@@ -8351,9 +8324,9 @@
                 <a:solidFill>
                   <a:srgbClr val="261E38"/>
                 </a:solidFill>
-                <a:latin typeface="Outfit" pitchFamily="34" charset="0"/>
-                <a:ea typeface="Outfit" pitchFamily="34" charset="-122"/>
-                <a:cs typeface="Outfit" pitchFamily="34" charset="-120"/>
+                <a:latin typeface="Times New Roman" pitchFamily="34" charset="0"/>
+                <a:ea typeface="Times New Roman" pitchFamily="34" charset="-122"/>
+                <a:cs typeface="Times New Roman" pitchFamily="34" charset="-120"/>
               </a:rPr>
               <a:t>Nuzzle</a:t>
             </a:r>
@@ -8390,9 +8363,9 @@
                 <a:solidFill>
                   <a:srgbClr val="5F5377"/>
                 </a:solidFill>
-                <a:latin typeface="Plus Jakarta Sans" pitchFamily="34" charset="0"/>
-                <a:ea typeface="Plus Jakarta Sans" pitchFamily="34" charset="-122"/>
-                <a:cs typeface="Plus Jakarta Sans" pitchFamily="34" charset="-120"/>
+                <a:latin typeface="Times New Roman" pitchFamily="34" charset="0"/>
+                <a:ea typeface="Times New Roman" pitchFamily="34" charset="-122"/>
+                <a:cs typeface="Times New Roman" pitchFamily="34" charset="-120"/>
               </a:rPr>
               <a:t>Deep affection &amp; snuggle</a:t>
             </a:r>
@@ -8490,9 +8463,9 @@
                 <a:solidFill>
                   <a:srgbClr val="261E38"/>
                 </a:solidFill>
-                <a:latin typeface="Outfit" pitchFamily="34" charset="0"/>
-                <a:ea typeface="Outfit" pitchFamily="34" charset="-122"/>
-                <a:cs typeface="Outfit" pitchFamily="34" charset="-120"/>
+                <a:latin typeface="Times New Roman" pitchFamily="34" charset="0"/>
+                <a:ea typeface="Times New Roman" pitchFamily="34" charset="-122"/>
+                <a:cs typeface="Times New Roman" pitchFamily="34" charset="-120"/>
               </a:rPr>
               <a:t>Tasty Treat</a:t>
             </a:r>
@@ -8529,9 +8502,9 @@
                 <a:solidFill>
                   <a:srgbClr val="5F5377"/>
                 </a:solidFill>
-                <a:latin typeface="Plus Jakarta Sans" pitchFamily="34" charset="0"/>
-                <a:ea typeface="Plus Jakarta Sans" pitchFamily="34" charset="-122"/>
-                <a:cs typeface="Plus Jakarta Sans" pitchFamily="34" charset="-120"/>
+                <a:latin typeface="Times New Roman" pitchFamily="34" charset="0"/>
+                <a:ea typeface="Times New Roman" pitchFamily="34" charset="-122"/>
+                <a:cs typeface="Times New Roman" pitchFamily="34" charset="-120"/>
               </a:rPr>
               <a:t>Reward for good behaviour</a:t>
             </a:r>
@@ -8629,9 +8602,9 @@
                 <a:solidFill>
                   <a:srgbClr val="261E38"/>
                 </a:solidFill>
-                <a:latin typeface="Outfit" pitchFamily="34" charset="0"/>
-                <a:ea typeface="Outfit" pitchFamily="34" charset="-122"/>
-                <a:cs typeface="Outfit" pitchFamily="34" charset="-120"/>
+                <a:latin typeface="Times New Roman" pitchFamily="34" charset="0"/>
+                <a:ea typeface="Times New Roman" pitchFamily="34" charset="-122"/>
+                <a:cs typeface="Times New Roman" pitchFamily="34" charset="-120"/>
               </a:rPr>
               <a:t>Tennis Ball</a:t>
             </a:r>
@@ -8668,9 +8641,9 @@
                 <a:solidFill>
                   <a:srgbClr val="5F5377"/>
                 </a:solidFill>
-                <a:latin typeface="Plus Jakarta Sans" pitchFamily="34" charset="0"/>
-                <a:ea typeface="Plus Jakarta Sans" pitchFamily="34" charset="-122"/>
-                <a:cs typeface="Plus Jakarta Sans" pitchFamily="34" charset="-120"/>
+                <a:latin typeface="Times New Roman" pitchFamily="34" charset="0"/>
+                <a:ea typeface="Times New Roman" pitchFamily="34" charset="-122"/>
+                <a:cs typeface="Times New Roman" pitchFamily="34" charset="-120"/>
               </a:rPr>
               <a:t>Playful energy &amp; zoomies</a:t>
             </a:r>
@@ -8768,9 +8741,9 @@
                 <a:solidFill>
                   <a:srgbClr val="261E38"/>
                 </a:solidFill>
-                <a:latin typeface="Outfit" pitchFamily="34" charset="0"/>
-                <a:ea typeface="Outfit" pitchFamily="34" charset="-122"/>
-                <a:cs typeface="Outfit" pitchFamily="34" charset="-120"/>
+                <a:latin typeface="Times New Roman" pitchFamily="34" charset="0"/>
+                <a:ea typeface="Times New Roman" pitchFamily="34" charset="-122"/>
+                <a:cs typeface="Times New Roman" pitchFamily="34" charset="-120"/>
               </a:rPr>
               <a:t>Heart Purr</a:t>
             </a:r>
@@ -8807,9 +8780,9 @@
                 <a:solidFill>
                   <a:srgbClr val="5F5377"/>
                 </a:solidFill>
-                <a:latin typeface="Plus Jakarta Sans" pitchFamily="34" charset="0"/>
-                <a:ea typeface="Plus Jakarta Sans" pitchFamily="34" charset="-122"/>
-                <a:cs typeface="Plus Jakarta Sans" pitchFamily="34" charset="-120"/>
+                <a:latin typeface="Times New Roman" pitchFamily="34" charset="0"/>
+                <a:ea typeface="Times New Roman" pitchFamily="34" charset="-122"/>
+                <a:cs typeface="Times New Roman" pitchFamily="34" charset="-120"/>
               </a:rPr>
               <a:t>Cat vocalization love</a:t>
             </a:r>
@@ -8903,9 +8876,9 @@
                 <a:solidFill>
                   <a:srgbClr val="7C3AED"/>
                 </a:solidFill>
-                <a:latin typeface="Outfit" pitchFamily="34" charset="0"/>
-                <a:ea typeface="Outfit" pitchFamily="34" charset="-122"/>
-                <a:cs typeface="Outfit" pitchFamily="34" charset="-120"/>
+                <a:latin typeface="Times New Roman" pitchFamily="34" charset="0"/>
+                <a:ea typeface="Times New Roman" pitchFamily="34" charset="-122"/>
+                <a:cs typeface="Times New Roman" pitchFamily="34" charset="-120"/>
               </a:rPr>
               <a:t>🐾 Nuzzle Engine</a:t>
             </a:r>
@@ -8942,9 +8915,9 @@
                 <a:solidFill>
                   <a:srgbClr val="5F5377"/>
                 </a:solidFill>
-                <a:latin typeface="Plus Jakarta Sans" pitchFamily="34" charset="0"/>
-                <a:ea typeface="Plus Jakarta Sans" pitchFamily="34" charset="-122"/>
-                <a:cs typeface="Plus Jakarta Sans" pitchFamily="34" charset="-120"/>
+                <a:latin typeface="Times New Roman" pitchFamily="34" charset="0"/>
+                <a:ea typeface="Times New Roman" pitchFamily="34" charset="-122"/>
+                <a:cs typeface="Times New Roman" pitchFamily="34" charset="-120"/>
               </a:rPr>
               <a:t>Slide 5 / 10 • Full-Stack REST API Architecture</a:t>
             </a:r>
@@ -8981,9 +8954,9 @@
                 <a:solidFill>
                   <a:srgbClr val="7C3AED"/>
                 </a:solidFill>
-                <a:latin typeface="Plus Jakarta Sans" pitchFamily="34" charset="0"/>
-                <a:ea typeface="Plus Jakarta Sans" pitchFamily="34" charset="-122"/>
-                <a:cs typeface="Plus Jakarta Sans" pitchFamily="34" charset="-120"/>
+                <a:latin typeface="Times New Roman" pitchFamily="34" charset="0"/>
+                <a:ea typeface="Times New Roman" pitchFamily="34" charset="-122"/>
+                <a:cs typeface="Times New Roman" pitchFamily="34" charset="-120"/>
               </a:rPr>
               <a:t>EMERGENCY RESCUE DISPATCH</a:t>
             </a:r>
@@ -9020,9 +8993,9 @@
                 <a:solidFill>
                   <a:srgbClr val="261E38"/>
                 </a:solidFill>
-                <a:latin typeface="Outfit" pitchFamily="34" charset="0"/>
-                <a:ea typeface="Outfit" pitchFamily="34" charset="-122"/>
-                <a:cs typeface="Outfit" pitchFamily="34" charset="-120"/>
+                <a:latin typeface="Times New Roman" pitchFamily="34" charset="0"/>
+                <a:ea typeface="Times New Roman" pitchFamily="34" charset="-122"/>
+                <a:cs typeface="Times New Roman" pitchFamily="34" charset="-120"/>
               </a:rPr>
               <a:t>5-Mile Radar Alert &amp; Volunteer Claim-and-Lock API</a:t>
             </a:r>
@@ -9082,9 +9055,9 @@
                 <a:solidFill>
                   <a:srgbClr val="9589B0"/>
                 </a:solidFill>
-                <a:latin typeface="Plus Jakarta Sans" pitchFamily="34" charset="0"/>
-                <a:ea typeface="Plus Jakarta Sans" pitchFamily="34" charset="-122"/>
-                <a:cs typeface="Plus Jakarta Sans" pitchFamily="34" charset="-120"/>
+                <a:latin typeface="Times New Roman" pitchFamily="34" charset="0"/>
+                <a:ea typeface="Times New Roman" pitchFamily="34" charset="-122"/>
+                <a:cs typeface="Times New Roman" pitchFamily="34" charset="-120"/>
               </a:rPr>
               <a:t>Nuzzle API v2.0 • Abu Zafor, Nadim Rahman, Rizvi Sarker • Technopreneurship 2026</a:t>
             </a:r>
@@ -9146,9 +9119,9 @@
                 <a:solidFill>
                   <a:srgbClr val="F43F5E"/>
                 </a:solidFill>
-                <a:latin typeface="Plus Jakarta Sans" pitchFamily="34" charset="0"/>
-                <a:ea typeface="Plus Jakarta Sans" pitchFamily="34" charset="-122"/>
-                <a:cs typeface="Plus Jakarta Sans" pitchFamily="34" charset="-120"/>
+                <a:latin typeface="Times New Roman" pitchFamily="34" charset="0"/>
+                <a:ea typeface="Times New Roman" pitchFamily="34" charset="-122"/>
+                <a:cs typeface="Times New Roman" pitchFamily="34" charset="-120"/>
               </a:rPr>
               <a:t>5-MILE GEOLOCATION RADAR</a:t>
             </a:r>
@@ -9188,9 +9161,9 @@
                 <a:solidFill>
                   <a:srgbClr val="5F5377"/>
                 </a:solidFill>
-                <a:latin typeface="Plus Jakarta Sans" pitchFamily="34" charset="0"/>
-                <a:ea typeface="Plus Jakarta Sans" pitchFamily="34" charset="-122"/>
-                <a:cs typeface="Plus Jakarta Sans" pitchFamily="34" charset="-120"/>
+                <a:latin typeface="Times New Roman" pitchFamily="34" charset="0"/>
+                <a:ea typeface="Times New Roman" pitchFamily="34" charset="-122"/>
+                <a:cs typeface="Times New Roman" pitchFamily="34" charset="-120"/>
               </a:rPr>
               <a:t>When a pet is reported lost, the Radar Engine broadcasts a high-priority push notification to all pet parents, verified stores, and clinics within a 5.0-mile radius.</a:t>
             </a:r>
@@ -9252,9 +9225,9 @@
                 <a:solidFill>
                   <a:srgbClr val="261E38"/>
                 </a:solidFill>
-                <a:latin typeface="Outfit" pitchFamily="34" charset="0"/>
-                <a:ea typeface="Outfit" pitchFamily="34" charset="-122"/>
-                <a:cs typeface="Outfit" pitchFamily="34" charset="-120"/>
+                <a:latin typeface="Times New Roman" pitchFamily="34" charset="0"/>
+                <a:ea typeface="Times New Roman" pitchFamily="34" charset="-122"/>
+                <a:cs typeface="Times New Roman" pitchFamily="34" charset="-120"/>
               </a:rPr>
               <a:t>🚨 Emergency Bounding Box</a:t>
             </a:r>
@@ -9294,9 +9267,9 @@
                 <a:solidFill>
                   <a:srgbClr val="5F5377"/>
                 </a:solidFill>
-                <a:latin typeface="Plus Jakarta Sans" pitchFamily="34" charset="0"/>
-                <a:ea typeface="Plus Jakarta Sans" pitchFamily="34" charset="-122"/>
-                <a:cs typeface="Plus Jakarta Sans" pitchFamily="34" charset="-120"/>
+                <a:latin typeface="Times New Roman" pitchFamily="34" charset="0"/>
+                <a:ea typeface="Times New Roman" pitchFamily="34" charset="-122"/>
+                <a:cs typeface="Times New Roman" pitchFamily="34" charset="-120"/>
               </a:rPr>
               <a:t>Queries PostgreSQL with lat/long distance math to return local alerts only.</a:t>
             </a:r>
@@ -9358,9 +9331,9 @@
                 <a:solidFill>
                   <a:srgbClr val="261E38"/>
                 </a:solidFill>
-                <a:latin typeface="Outfit" pitchFamily="34" charset="0"/>
-                <a:ea typeface="Outfit" pitchFamily="34" charset="-122"/>
-                <a:cs typeface="Outfit" pitchFamily="34" charset="-120"/>
+                <a:latin typeface="Times New Roman" pitchFamily="34" charset="0"/>
+                <a:ea typeface="Times New Roman" pitchFamily="34" charset="-122"/>
+                <a:cs typeface="Times New Roman" pitchFamily="34" charset="-120"/>
               </a:rPr>
               <a:t>🔒 Claim-and-Lock Rescue Protocol</a:t>
             </a:r>
@@ -9400,9 +9373,9 @@
                 <a:solidFill>
                   <a:srgbClr val="5F5377"/>
                 </a:solidFill>
-                <a:latin typeface="Plus Jakarta Sans" pitchFamily="34" charset="0"/>
-                <a:ea typeface="Plus Jakarta Sans" pitchFamily="34" charset="-122"/>
-                <a:cs typeface="Plus Jakarta Sans" pitchFamily="34" charset="-120"/>
+                <a:latin typeface="Times New Roman" pitchFamily="34" charset="0"/>
+                <a:ea typeface="Times New Roman" pitchFamily="34" charset="-122"/>
+                <a:cs typeface="Times New Roman" pitchFamily="34" charset="-120"/>
               </a:rPr>
               <a:t>POST /api/lost-found/:id/claim locks rescue case to 1 volunteer to prevent duplicate dispatches.</a:t>
             </a:r>
@@ -9464,9 +9437,9 @@
                 <a:solidFill>
                   <a:srgbClr val="261E38"/>
                 </a:solidFill>
-                <a:latin typeface="Outfit" pitchFamily="34" charset="0"/>
-                <a:ea typeface="Outfit" pitchFamily="34" charset="-122"/>
-                <a:cs typeface="Outfit" pitchFamily="34" charset="-120"/>
+                <a:latin typeface="Times New Roman" pitchFamily="34" charset="0"/>
+                <a:ea typeface="Times New Roman" pitchFamily="34" charset="-122"/>
+                <a:cs typeface="Times New Roman" pitchFamily="34" charset="-120"/>
               </a:rPr>
               <a:t>💰 Bounty &amp; Identification</a:t>
             </a:r>
@@ -9506,9 +9479,9 @@
                 <a:solidFill>
                   <a:srgbClr val="5F5377"/>
                 </a:solidFill>
-                <a:latin typeface="Plus Jakarta Sans" pitchFamily="34" charset="0"/>
-                <a:ea typeface="Plus Jakarta Sans" pitchFamily="34" charset="-122"/>
-                <a:cs typeface="Plus Jakarta Sans" pitchFamily="34" charset="-120"/>
+                <a:latin typeface="Times New Roman" pitchFamily="34" charset="0"/>
+                <a:ea typeface="Times New Roman" pitchFamily="34" charset="-122"/>
+                <a:cs typeface="Times New Roman" pitchFamily="34" charset="-120"/>
               </a:rPr>
               <a:t>Displays microchip ID, collar tags, distinctive markings, and optional rescue rewards.</a:t>
             </a:r>
@@ -9570,9 +9543,9 @@
                 <a:solidFill>
                   <a:srgbClr val="947DEE"/>
                 </a:solidFill>
-                <a:latin typeface="Plus Jakarta Sans" pitchFamily="34" charset="0"/>
-                <a:ea typeface="Plus Jakarta Sans" pitchFamily="34" charset="-122"/>
-                <a:cs typeface="Plus Jakarta Sans" pitchFamily="34" charset="-120"/>
+                <a:latin typeface="Times New Roman" pitchFamily="34" charset="0"/>
+                <a:ea typeface="Times New Roman" pitchFamily="34" charset="-122"/>
+                <a:cs typeface="Times New Roman" pitchFamily="34" charset="-120"/>
               </a:rPr>
               <a:t>RADAR ALERT PAYLOAD SCHEMA</a:t>
             </a:r>
@@ -9997,9 +9970,9 @@
                 <a:solidFill>
                   <a:srgbClr val="7C3AED"/>
                 </a:solidFill>
-                <a:latin typeface="Outfit" pitchFamily="34" charset="0"/>
-                <a:ea typeface="Outfit" pitchFamily="34" charset="-122"/>
-                <a:cs typeface="Outfit" pitchFamily="34" charset="-120"/>
+                <a:latin typeface="Times New Roman" pitchFamily="34" charset="0"/>
+                <a:ea typeface="Times New Roman" pitchFamily="34" charset="-122"/>
+                <a:cs typeface="Times New Roman" pitchFamily="34" charset="-120"/>
               </a:rPr>
               <a:t>🐾 Nuzzle Engine</a:t>
             </a:r>
@@ -10036,9 +10009,9 @@
                 <a:solidFill>
                   <a:srgbClr val="5F5377"/>
                 </a:solidFill>
-                <a:latin typeface="Plus Jakarta Sans" pitchFamily="34" charset="0"/>
-                <a:ea typeface="Plus Jakarta Sans" pitchFamily="34" charset="-122"/>
-                <a:cs typeface="Plus Jakarta Sans" pitchFamily="34" charset="-120"/>
+                <a:latin typeface="Times New Roman" pitchFamily="34" charset="0"/>
+                <a:ea typeface="Times New Roman" pitchFamily="34" charset="-122"/>
+                <a:cs typeface="Times New Roman" pitchFamily="34" charset="-120"/>
               </a:rPr>
               <a:t>Slide 6 / 10 • Full-Stack REST API Architecture</a:t>
             </a:r>
@@ -10075,9 +10048,9 @@
                 <a:solidFill>
                   <a:srgbClr val="7C3AED"/>
                 </a:solidFill>
-                <a:latin typeface="Plus Jakarta Sans" pitchFamily="34" charset="0"/>
-                <a:ea typeface="Plus Jakarta Sans" pitchFamily="34" charset="-122"/>
-                <a:cs typeface="Plus Jakarta Sans" pitchFamily="34" charset="-120"/>
+                <a:latin typeface="Times New Roman" pitchFamily="34" charset="0"/>
+                <a:ea typeface="Times New Roman" pitchFamily="34" charset="-122"/>
+                <a:cs typeface="Times New Roman" pitchFamily="34" charset="-120"/>
               </a:rPr>
               <a:t>TELEMEDICINE &amp; CLINICAL CARE</a:t>
             </a:r>
@@ -10114,9 +10087,9 @@
                 <a:solidFill>
                   <a:srgbClr val="261E38"/>
                 </a:solidFill>
-                <a:latin typeface="Outfit" pitchFamily="34" charset="0"/>
-                <a:ea typeface="Outfit" pitchFamily="34" charset="-122"/>
-                <a:cs typeface="Outfit" pitchFamily="34" charset="-120"/>
+                <a:latin typeface="Times New Roman" pitchFamily="34" charset="0"/>
+                <a:ea typeface="Times New Roman" pitchFamily="34" charset="-122"/>
+                <a:cs typeface="Times New Roman" pitchFamily="34" charset="-120"/>
               </a:rPr>
               <a:t>Veterinary Directory &amp; Appointment Scheduling API</a:t>
             </a:r>
@@ -10176,9 +10149,9 @@
                 <a:solidFill>
                   <a:srgbClr val="9589B0"/>
                 </a:solidFill>
-                <a:latin typeface="Plus Jakarta Sans" pitchFamily="34" charset="0"/>
-                <a:ea typeface="Plus Jakarta Sans" pitchFamily="34" charset="-122"/>
-                <a:cs typeface="Plus Jakarta Sans" pitchFamily="34" charset="-120"/>
+                <a:latin typeface="Times New Roman" pitchFamily="34" charset="0"/>
+                <a:ea typeface="Times New Roman" pitchFamily="34" charset="-122"/>
+                <a:cs typeface="Times New Roman" pitchFamily="34" charset="-120"/>
               </a:rPr>
               <a:t>Nuzzle API v2.0 • Abu Zafor, Nadim Rahman, Rizvi Sarker • Technopreneurship 2026</a:t>
             </a:r>
@@ -10240,9 +10213,9 @@
                 <a:solidFill>
                   <a:srgbClr val="261E38"/>
                 </a:solidFill>
-                <a:latin typeface="Outfit" pitchFamily="34" charset="0"/>
-                <a:ea typeface="Outfit" pitchFamily="34" charset="-122"/>
-                <a:cs typeface="Outfit" pitchFamily="34" charset="-120"/>
+                <a:latin typeface="Times New Roman" pitchFamily="34" charset="0"/>
+                <a:ea typeface="Times New Roman" pitchFamily="34" charset="-122"/>
+                <a:cs typeface="Times New Roman" pitchFamily="34" charset="-120"/>
               </a:rPr>
               <a:t>Verified Clinic Directory</a:t>
             </a:r>
@@ -10321,9 +10294,9 @@
                 <a:solidFill>
                   <a:srgbClr val="5F5377"/>
                 </a:solidFill>
-                <a:latin typeface="Plus Jakarta Sans" pitchFamily="34" charset="0"/>
-                <a:ea typeface="Plus Jakarta Sans" pitchFamily="34" charset="-122"/>
-                <a:cs typeface="Plus Jakarta Sans" pitchFamily="34" charset="-120"/>
+                <a:latin typeface="Times New Roman" pitchFamily="34" charset="0"/>
+                <a:ea typeface="Times New Roman" pitchFamily="34" charset="-122"/>
+                <a:cs typeface="Times New Roman" pitchFamily="34" charset="-120"/>
               </a:rPr>
               <a:t>Returns accredited veterinary hospitals in Dhaka with ratings, distance radius, and emergency badges.</a:t>
             </a:r>
@@ -10408,9 +10381,9 @@
                 <a:solidFill>
                   <a:srgbClr val="261E38"/>
                 </a:solidFill>
-                <a:latin typeface="Plus Jakarta Sans" pitchFamily="34" charset="0"/>
-                <a:ea typeface="Plus Jakarta Sans" pitchFamily="34" charset="-122"/>
-                <a:cs typeface="Plus Jakarta Sans" pitchFamily="34" charset="-120"/>
+                <a:latin typeface="Times New Roman" pitchFamily="34" charset="0"/>
+                <a:ea typeface="Times New Roman" pitchFamily="34" charset="-122"/>
+                <a:cs typeface="Times New Roman" pitchFamily="34" charset="-120"/>
               </a:rPr>
               <a:t>✓ Dr. Sarah Al-Mansoor (Cascade 24/7)</a:t>
             </a:r>
@@ -10472,9 +10445,9 @@
                 <a:solidFill>
                   <a:srgbClr val="261E38"/>
                 </a:solidFill>
-                <a:latin typeface="Plus Jakarta Sans" pitchFamily="34" charset="0"/>
-                <a:ea typeface="Plus Jakarta Sans" pitchFamily="34" charset="-122"/>
-                <a:cs typeface="Plus Jakarta Sans" pitchFamily="34" charset="-120"/>
+                <a:latin typeface="Times New Roman" pitchFamily="34" charset="0"/>
+                <a:ea typeface="Times New Roman" pitchFamily="34" charset="-122"/>
+                <a:cs typeface="Times New Roman" pitchFamily="34" charset="-120"/>
               </a:rPr>
               <a:t>✓ Dr. Marcus Lee (Bay Area Exotic)</a:t>
             </a:r>
@@ -10536,9 +10509,9 @@
                 <a:solidFill>
                   <a:srgbClr val="261E38"/>
                 </a:solidFill>
-                <a:latin typeface="Plus Jakarta Sans" pitchFamily="34" charset="0"/>
-                <a:ea typeface="Plus Jakarta Sans" pitchFamily="34" charset="-122"/>
-                <a:cs typeface="Plus Jakarta Sans" pitchFamily="34" charset="-120"/>
+                <a:latin typeface="Times New Roman" pitchFamily="34" charset="0"/>
+                <a:ea typeface="Times New Roman" pitchFamily="34" charset="-122"/>
+                <a:cs typeface="Times New Roman" pitchFamily="34" charset="-120"/>
               </a:rPr>
               <a:t>✓ Dr. Priya Nair (Sunnyvale Wellness)</a:t>
             </a:r>
@@ -10600,9 +10573,9 @@
                 <a:solidFill>
                   <a:srgbClr val="261E38"/>
                 </a:solidFill>
-                <a:latin typeface="Outfit" pitchFamily="34" charset="0"/>
-                <a:ea typeface="Outfit" pitchFamily="34" charset="-122"/>
-                <a:cs typeface="Outfit" pitchFamily="34" charset="-120"/>
+                <a:latin typeface="Times New Roman" pitchFamily="34" charset="0"/>
+                <a:ea typeface="Times New Roman" pitchFamily="34" charset="-122"/>
+                <a:cs typeface="Times New Roman" pitchFamily="34" charset="-120"/>
               </a:rPr>
               <a:t>Pro Priority Placement</a:t>
             </a:r>
@@ -10681,9 +10654,9 @@
                 <a:solidFill>
                   <a:srgbClr val="5F5377"/>
                 </a:solidFill>
-                <a:latin typeface="Plus Jakarta Sans" pitchFamily="34" charset="0"/>
-                <a:ea typeface="Plus Jakarta Sans" pitchFamily="34" charset="-122"/>
-                <a:cs typeface="Plus Jakarta Sans" pitchFamily="34" charset="-120"/>
+                <a:latin typeface="Times New Roman" pitchFamily="34" charset="0"/>
+                <a:ea typeface="Times New Roman" pitchFamily="34" charset="-122"/>
+                <a:cs typeface="Times New Roman" pitchFamily="34" charset="-120"/>
               </a:rPr>
               <a:t>Subscribed partner clinics receive guaranteed #1 priority placement in PawAI triage suggestions.</a:t>
             </a:r>
@@ -10768,9 +10741,9 @@
                 <a:solidFill>
                   <a:srgbClr val="261E38"/>
                 </a:solidFill>
-                <a:latin typeface="Plus Jakarta Sans" pitchFamily="34" charset="0"/>
-                <a:ea typeface="Plus Jakarta Sans" pitchFamily="34" charset="-122"/>
-                <a:cs typeface="Plus Jakarta Sans" pitchFamily="34" charset="-120"/>
+                <a:latin typeface="Times New Roman" pitchFamily="34" charset="0"/>
+                <a:ea typeface="Times New Roman" pitchFamily="34" charset="-122"/>
+                <a:cs typeface="Times New Roman" pitchFamily="34" charset="-120"/>
               </a:rPr>
               <a:t>✓ Gold Clinic Shield Badge</a:t>
             </a:r>
@@ -10832,9 +10805,9 @@
                 <a:solidFill>
                   <a:srgbClr val="261E38"/>
                 </a:solidFill>
-                <a:latin typeface="Plus Jakarta Sans" pitchFamily="34" charset="0"/>
-                <a:ea typeface="Plus Jakarta Sans" pitchFamily="34" charset="-122"/>
-                <a:cs typeface="Plus Jakarta Sans" pitchFamily="34" charset="-120"/>
+                <a:latin typeface="Times New Roman" pitchFamily="34" charset="0"/>
+                <a:ea typeface="Times New Roman" pitchFamily="34" charset="-122"/>
+                <a:cs typeface="Times New Roman" pitchFamily="34" charset="-120"/>
               </a:rPr>
               <a:t>✓ Instant Triage Log Handoff</a:t>
             </a:r>
@@ -10896,9 +10869,9 @@
                 <a:solidFill>
                   <a:srgbClr val="261E38"/>
                 </a:solidFill>
-                <a:latin typeface="Plus Jakarta Sans" pitchFamily="34" charset="0"/>
-                <a:ea typeface="Plus Jakarta Sans" pitchFamily="34" charset="-122"/>
-                <a:cs typeface="Plus Jakarta Sans" pitchFamily="34" charset="-120"/>
+                <a:latin typeface="Times New Roman" pitchFamily="34" charset="0"/>
+                <a:ea typeface="Times New Roman" pitchFamily="34" charset="-122"/>
+                <a:cs typeface="Times New Roman" pitchFamily="34" charset="-120"/>
               </a:rPr>
               <a:t>✓ 0% Booking Commission</a:t>
             </a:r>
@@ -10960,9 +10933,9 @@
                 <a:solidFill>
                   <a:srgbClr val="261E38"/>
                 </a:solidFill>
-                <a:latin typeface="Outfit" pitchFamily="34" charset="0"/>
-                <a:ea typeface="Outfit" pitchFamily="34" charset="-122"/>
-                <a:cs typeface="Outfit" pitchFamily="34" charset="-120"/>
+                <a:latin typeface="Times New Roman" pitchFamily="34" charset="0"/>
+                <a:ea typeface="Times New Roman" pitchFamily="34" charset="-122"/>
+                <a:cs typeface="Times New Roman" pitchFamily="34" charset="-120"/>
               </a:rPr>
               <a:t>Slot Scheduling Engine</a:t>
             </a:r>
@@ -11041,9 +11014,9 @@
                 <a:solidFill>
                   <a:srgbClr val="5F5377"/>
                 </a:solidFill>
-                <a:latin typeface="Plus Jakarta Sans" pitchFamily="34" charset="0"/>
-                <a:ea typeface="Plus Jakarta Sans" pitchFamily="34" charset="-122"/>
-                <a:cs typeface="Plus Jakarta Sans" pitchFamily="34" charset="-120"/>
+                <a:latin typeface="Times New Roman" pitchFamily="34" charset="0"/>
+                <a:ea typeface="Times New Roman" pitchFamily="34" charset="-122"/>
+                <a:cs typeface="Times New Roman" pitchFamily="34" charset="-120"/>
               </a:rPr>
               <a:t>Pet parents book physical or virtual consultations with real-time slot conflict prevention.</a:t>
             </a:r>
@@ -11128,9 +11101,9 @@
                 <a:solidFill>
                   <a:srgbClr val="261E38"/>
                 </a:solidFill>
-                <a:latin typeface="Plus Jakarta Sans" pitchFamily="34" charset="0"/>
-                <a:ea typeface="Plus Jakarta Sans" pitchFamily="34" charset="-122"/>
-                <a:cs typeface="Plus Jakarta Sans" pitchFamily="34" charset="-120"/>
+                <a:latin typeface="Times New Roman" pitchFamily="34" charset="0"/>
+                <a:ea typeface="Times New Roman" pitchFamily="34" charset="-122"/>
+                <a:cs typeface="Times New Roman" pitchFamily="34" charset="-120"/>
               </a:rPr>
               <a:t>✓ Vaccination &amp; Checkups</a:t>
             </a:r>
@@ -11192,9 +11165,9 @@
                 <a:solidFill>
                   <a:srgbClr val="261E38"/>
                 </a:solidFill>
-                <a:latin typeface="Plus Jakarta Sans" pitchFamily="34" charset="0"/>
-                <a:ea typeface="Plus Jakarta Sans" pitchFamily="34" charset="-122"/>
-                <a:cs typeface="Plus Jakarta Sans" pitchFamily="34" charset="-120"/>
+                <a:latin typeface="Times New Roman" pitchFamily="34" charset="0"/>
+                <a:ea typeface="Times New Roman" pitchFamily="34" charset="-122"/>
+                <a:cs typeface="Times New Roman" pitchFamily="34" charset="-120"/>
               </a:rPr>
               <a:t>✓ Emergency Trauma Booking</a:t>
             </a:r>
@@ -11256,9 +11229,9 @@
                 <a:solidFill>
                   <a:srgbClr val="261E38"/>
                 </a:solidFill>
-                <a:latin typeface="Plus Jakarta Sans" pitchFamily="34" charset="0"/>
-                <a:ea typeface="Plus Jakarta Sans" pitchFamily="34" charset="-122"/>
-                <a:cs typeface="Plus Jakarta Sans" pitchFamily="34" charset="-120"/>
+                <a:latin typeface="Times New Roman" pitchFamily="34" charset="0"/>
+                <a:ea typeface="Times New Roman" pitchFamily="34" charset="-122"/>
+                <a:cs typeface="Times New Roman" pitchFamily="34" charset="-120"/>
               </a:rPr>
               <a:t>✓ Adoption Meet &amp; Greets</a:t>
             </a:r>
@@ -11352,9 +11325,9 @@
                 <a:solidFill>
                   <a:srgbClr val="7C3AED"/>
                 </a:solidFill>
-                <a:latin typeface="Outfit" pitchFamily="34" charset="0"/>
-                <a:ea typeface="Outfit" pitchFamily="34" charset="-122"/>
-                <a:cs typeface="Outfit" pitchFamily="34" charset="-120"/>
+                <a:latin typeface="Times New Roman" pitchFamily="34" charset="0"/>
+                <a:ea typeface="Times New Roman" pitchFamily="34" charset="-122"/>
+                <a:cs typeface="Times New Roman" pitchFamily="34" charset="-120"/>
               </a:rPr>
               <a:t>🐾 Nuzzle Engine</a:t>
             </a:r>
@@ -11391,9 +11364,9 @@
                 <a:solidFill>
                   <a:srgbClr val="5F5377"/>
                 </a:solidFill>
-                <a:latin typeface="Plus Jakarta Sans" pitchFamily="34" charset="0"/>
-                <a:ea typeface="Plus Jakarta Sans" pitchFamily="34" charset="-122"/>
-                <a:cs typeface="Plus Jakarta Sans" pitchFamily="34" charset="-120"/>
+                <a:latin typeface="Times New Roman" pitchFamily="34" charset="0"/>
+                <a:ea typeface="Times New Roman" pitchFamily="34" charset="-122"/>
+                <a:cs typeface="Times New Roman" pitchFamily="34" charset="-120"/>
               </a:rPr>
               <a:t>Slide 7 / 10 • Full-Stack REST API Architecture</a:t>
             </a:r>
@@ -11430,9 +11403,9 @@
                 <a:solidFill>
                   <a:srgbClr val="7C3AED"/>
                 </a:solidFill>
-                <a:latin typeface="Plus Jakarta Sans" pitchFamily="34" charset="0"/>
-                <a:ea typeface="Plus Jakarta Sans" pitchFamily="34" charset="-122"/>
-                <a:cs typeface="Plus Jakarta Sans" pitchFamily="34" charset="-120"/>
+                <a:latin typeface="Times New Roman" pitchFamily="34" charset="0"/>
+                <a:ea typeface="Times New Roman" pitchFamily="34" charset="-122"/>
+                <a:cs typeface="Times New Roman" pitchFamily="34" charset="-120"/>
               </a:rPr>
               <a:t>COMMERCE &amp; ADOPTION HUBS</a:t>
             </a:r>
@@ -11469,9 +11442,9 @@
                 <a:solidFill>
                   <a:srgbClr val="261E38"/>
                 </a:solidFill>
-                <a:latin typeface="Outfit" pitchFamily="34" charset="0"/>
-                <a:ea typeface="Outfit" pitchFamily="34" charset="-122"/>
-                <a:cs typeface="Outfit" pitchFamily="34" charset="-120"/>
+                <a:latin typeface="Times New Roman" pitchFamily="34" charset="0"/>
+                <a:ea typeface="Times New Roman" pitchFamily="34" charset="-122"/>
+                <a:cs typeface="Times New Roman" pitchFamily="34" charset="-120"/>
               </a:rPr>
               <a:t>Verified Pet Boutique &amp; Adoption Listings API</a:t>
             </a:r>
@@ -11531,9 +11504,9 @@
                 <a:solidFill>
                   <a:srgbClr val="9589B0"/>
                 </a:solidFill>
-                <a:latin typeface="Plus Jakarta Sans" pitchFamily="34" charset="0"/>
-                <a:ea typeface="Plus Jakarta Sans" pitchFamily="34" charset="-122"/>
-                <a:cs typeface="Plus Jakarta Sans" pitchFamily="34" charset="-120"/>
+                <a:latin typeface="Times New Roman" pitchFamily="34" charset="0"/>
+                <a:ea typeface="Times New Roman" pitchFamily="34" charset="-122"/>
+                <a:cs typeface="Times New Roman" pitchFamily="34" charset="-120"/>
               </a:rPr>
               <a:t>Nuzzle API v2.0 • Abu Zafor, Nadim Rahman, Rizvi Sarker • Technopreneurship 2026</a:t>
             </a:r>
@@ -11595,9 +11568,9 @@
                 <a:solidFill>
                   <a:srgbClr val="7C3AED"/>
                 </a:solidFill>
-                <a:latin typeface="Plus Jakarta Sans" pitchFamily="34" charset="0"/>
-                <a:ea typeface="Plus Jakarta Sans" pitchFamily="34" charset="-122"/>
-                <a:cs typeface="Plus Jakarta Sans" pitchFamily="34" charset="-120"/>
+                <a:latin typeface="Times New Roman" pitchFamily="34" charset="0"/>
+                <a:ea typeface="Times New Roman" pitchFamily="34" charset="-122"/>
+                <a:cs typeface="Times New Roman" pitchFamily="34" charset="-120"/>
               </a:rPr>
               <a:t>🛍️ VERIFIED PET MARKETPLACE API</a:t>
             </a:r>
@@ -11659,9 +11632,9 @@
                 <a:solidFill>
                   <a:srgbClr val="261E38"/>
                 </a:solidFill>
-                <a:latin typeface="Outfit" pitchFamily="34" charset="0"/>
-                <a:ea typeface="Outfit" pitchFamily="34" charset="-122"/>
-                <a:cs typeface="Outfit" pitchFamily="34" charset="-120"/>
+                <a:latin typeface="Times New Roman" pitchFamily="34" charset="0"/>
+                <a:ea typeface="Times New Roman" pitchFamily="34" charset="-122"/>
+                <a:cs typeface="Times New Roman" pitchFamily="34" charset="-120"/>
               </a:rPr>
               <a:t>GET /api/marketplace</a:t>
             </a:r>
@@ -11701,9 +11674,9 @@
                 <a:solidFill>
                   <a:srgbClr val="5F5377"/>
                 </a:solidFill>
-                <a:latin typeface="Plus Jakarta Sans" pitchFamily="34" charset="0"/>
-                <a:ea typeface="Plus Jakarta Sans" pitchFamily="34" charset="-122"/>
-                <a:cs typeface="Plus Jakarta Sans" pitchFamily="34" charset="-120"/>
+                <a:latin typeface="Times New Roman" pitchFamily="34" charset="0"/>
+                <a:ea typeface="Times New Roman" pitchFamily="34" charset="-122"/>
+                <a:cs typeface="Times New Roman" pitchFamily="34" charset="-120"/>
               </a:rPr>
               <a:t>Filtered product catalog by Category (Food, Toys, Beds, Apparel, Health).</a:t>
             </a:r>
@@ -11765,9 +11738,9 @@
                 <a:solidFill>
                   <a:srgbClr val="261E38"/>
                 </a:solidFill>
-                <a:latin typeface="Outfit" pitchFamily="34" charset="0"/>
-                <a:ea typeface="Outfit" pitchFamily="34" charset="-122"/>
-                <a:cs typeface="Outfit" pitchFamily="34" charset="-120"/>
+                <a:latin typeface="Times New Roman" pitchFamily="34" charset="0"/>
+                <a:ea typeface="Times New Roman" pitchFamily="34" charset="-122"/>
+                <a:cs typeface="Times New Roman" pitchFamily="34" charset="-120"/>
               </a:rPr>
               <a:t>POST /api/marketplace</a:t>
             </a:r>
@@ -11807,9 +11780,9 @@
                 <a:solidFill>
                   <a:srgbClr val="5F5377"/>
                 </a:solidFill>
-                <a:latin typeface="Plus Jakarta Sans" pitchFamily="34" charset="0"/>
-                <a:ea typeface="Plus Jakarta Sans" pitchFamily="34" charset="-122"/>
-                <a:cs typeface="Plus Jakarta Sans" pitchFamily="34" charset="-120"/>
+                <a:latin typeface="Times New Roman" pitchFamily="34" charset="0"/>
+                <a:ea typeface="Times New Roman" pitchFamily="34" charset="-122"/>
+                <a:cs typeface="Times New Roman" pitchFamily="34" charset="-120"/>
               </a:rPr>
               <a:t>Verified merchants list authentic products with stock counts, pricing &amp; images.</a:t>
             </a:r>
@@ -11871,9 +11844,9 @@
                 <a:solidFill>
                   <a:srgbClr val="261E38"/>
                 </a:solidFill>
-                <a:latin typeface="Outfit" pitchFamily="34" charset="0"/>
-                <a:ea typeface="Outfit" pitchFamily="34" charset="-122"/>
-                <a:cs typeface="Outfit" pitchFamily="34" charset="-120"/>
+                <a:latin typeface="Times New Roman" pitchFamily="34" charset="0"/>
+                <a:ea typeface="Times New Roman" pitchFamily="34" charset="-122"/>
+                <a:cs typeface="Times New Roman" pitchFamily="34" charset="-120"/>
               </a:rPr>
               <a:t>Gold Shield Verification</a:t>
             </a:r>
@@ -11913,9 +11886,9 @@
                 <a:solidFill>
                   <a:srgbClr val="5F5377"/>
                 </a:solidFill>
-                <a:latin typeface="Plus Jakarta Sans" pitchFamily="34" charset="0"/>
-                <a:ea typeface="Plus Jakarta Sans" pitchFamily="34" charset="-122"/>
-                <a:cs typeface="Plus Jakarta Sans" pitchFamily="34" charset="-120"/>
+                <a:latin typeface="Times New Roman" pitchFamily="34" charset="0"/>
+                <a:ea typeface="Times New Roman" pitchFamily="34" charset="-122"/>
+                <a:cs typeface="Times New Roman" pitchFamily="34" charset="-120"/>
               </a:rPr>
               <a:t>Verified stores get official badge &amp; priority placement across marketplace feeds.</a:t>
             </a:r>
@@ -11977,9 +11950,9 @@
                 <a:solidFill>
                   <a:srgbClr val="0284C7"/>
                 </a:solidFill>
-                <a:latin typeface="Plus Jakarta Sans" pitchFamily="34" charset="0"/>
-                <a:ea typeface="Plus Jakarta Sans" pitchFamily="34" charset="-122"/>
-                <a:cs typeface="Plus Jakarta Sans" pitchFamily="34" charset="-120"/>
+                <a:latin typeface="Times New Roman" pitchFamily="34" charset="0"/>
+                <a:ea typeface="Times New Roman" pitchFamily="34" charset="-122"/>
+                <a:cs typeface="Times New Roman" pitchFamily="34" charset="-120"/>
               </a:rPr>
               <a:t>🏠 RESCUE &amp; ADOPTION NETWORK API</a:t>
             </a:r>
@@ -12041,9 +12014,9 @@
                 <a:solidFill>
                   <a:srgbClr val="261E38"/>
                 </a:solidFill>
-                <a:latin typeface="Outfit" pitchFamily="34" charset="0"/>
-                <a:ea typeface="Outfit" pitchFamily="34" charset="-122"/>
-                <a:cs typeface="Outfit" pitchFamily="34" charset="-120"/>
+                <a:latin typeface="Times New Roman" pitchFamily="34" charset="0"/>
+                <a:ea typeface="Times New Roman" pitchFamily="34" charset="-122"/>
+                <a:cs typeface="Times New Roman" pitchFamily="34" charset="-120"/>
               </a:rPr>
               <a:t>GET /api/adoption</a:t>
             </a:r>
@@ -12083,9 +12056,9 @@
                 <a:solidFill>
                   <a:srgbClr val="5F5377"/>
                 </a:solidFill>
-                <a:latin typeface="Plus Jakarta Sans" pitchFamily="34" charset="0"/>
-                <a:ea typeface="Plus Jakarta Sans" pitchFamily="34" charset="-122"/>
-                <a:cs typeface="Plus Jakarta Sans" pitchFamily="34" charset="-120"/>
+                <a:latin typeface="Times New Roman" pitchFamily="34" charset="0"/>
+                <a:ea typeface="Times New Roman" pitchFamily="34" charset="-122"/>
+                <a:cs typeface="Times New Roman" pitchFamily="34" charset="-120"/>
               </a:rPr>
               <a:t>Lists shelter &amp; rescue pets with age, breed, gender, and temperament tags.</a:t>
             </a:r>
@@ -12147,9 +12120,9 @@
                 <a:solidFill>
                   <a:srgbClr val="261E38"/>
                 </a:solidFill>
-                <a:latin typeface="Outfit" pitchFamily="34" charset="0"/>
-                <a:ea typeface="Outfit" pitchFamily="34" charset="-122"/>
-                <a:cs typeface="Outfit" pitchFamily="34" charset="-120"/>
+                <a:latin typeface="Times New Roman" pitchFamily="34" charset="0"/>
+                <a:ea typeface="Times New Roman" pitchFamily="34" charset="-122"/>
+                <a:cs typeface="Times New Roman" pitchFamily="34" charset="-120"/>
               </a:rPr>
               <a:t>Vaccination &amp; Neutered Badges</a:t>
             </a:r>
@@ -12189,9 +12162,9 @@
                 <a:solidFill>
                   <a:srgbClr val="5F5377"/>
                 </a:solidFill>
-                <a:latin typeface="Plus Jakarta Sans" pitchFamily="34" charset="0"/>
-                <a:ea typeface="Plus Jakarta Sans" pitchFamily="34" charset="-122"/>
-                <a:cs typeface="Plus Jakarta Sans" pitchFamily="34" charset="-120"/>
+                <a:latin typeface="Times New Roman" pitchFamily="34" charset="0"/>
+                <a:ea typeface="Times New Roman" pitchFamily="34" charset="-122"/>
+                <a:cs typeface="Times New Roman" pitchFamily="34" charset="-120"/>
               </a:rPr>
               <a:t>Each pet profile carries verified medical records and shelter background.</a:t>
             </a:r>
@@ -12253,9 +12226,9 @@
                 <a:solidFill>
                   <a:srgbClr val="261E38"/>
                 </a:solidFill>
-                <a:latin typeface="Outfit" pitchFamily="34" charset="0"/>
-                <a:ea typeface="Outfit" pitchFamily="34" charset="-122"/>
-                <a:cs typeface="Outfit" pitchFamily="34" charset="-120"/>
+                <a:latin typeface="Times New Roman" pitchFamily="34" charset="0"/>
+                <a:ea typeface="Times New Roman" pitchFamily="34" charset="-122"/>
+                <a:cs typeface="Times New Roman" pitchFamily="34" charset="-120"/>
               </a:rPr>
               <a:t>Meet &amp; Greet Scheduling</a:t>
             </a:r>
@@ -12295,9 +12268,9 @@
                 <a:solidFill>
                   <a:srgbClr val="5F5377"/>
                 </a:solidFill>
-                <a:latin typeface="Plus Jakarta Sans" pitchFamily="34" charset="0"/>
-                <a:ea typeface="Plus Jakarta Sans" pitchFamily="34" charset="-122"/>
-                <a:cs typeface="Plus Jakarta Sans" pitchFamily="34" charset="-120"/>
+                <a:latin typeface="Times New Roman" pitchFamily="34" charset="0"/>
+                <a:ea typeface="Times New Roman" pitchFamily="34" charset="-122"/>
+                <a:cs typeface="Times New Roman" pitchFamily="34" charset="-120"/>
               </a:rPr>
               <a:t>Direct adoption inquiry flow syncing with veterinary calendar slots.</a:t>
             </a:r>
@@ -12391,9 +12364,9 @@
                 <a:solidFill>
                   <a:srgbClr val="7C3AED"/>
                 </a:solidFill>
-                <a:latin typeface="Outfit" pitchFamily="34" charset="0"/>
-                <a:ea typeface="Outfit" pitchFamily="34" charset="-122"/>
-                <a:cs typeface="Outfit" pitchFamily="34" charset="-120"/>
+                <a:latin typeface="Times New Roman" pitchFamily="34" charset="0"/>
+                <a:ea typeface="Times New Roman" pitchFamily="34" charset="-122"/>
+                <a:cs typeface="Times New Roman" pitchFamily="34" charset="-120"/>
               </a:rPr>
               <a:t>🐾 Nuzzle Engine</a:t>
             </a:r>
@@ -12430,9 +12403,9 @@
                 <a:solidFill>
                   <a:srgbClr val="5F5377"/>
                 </a:solidFill>
-                <a:latin typeface="Plus Jakarta Sans" pitchFamily="34" charset="0"/>
-                <a:ea typeface="Plus Jakarta Sans" pitchFamily="34" charset="-122"/>
-                <a:cs typeface="Plus Jakarta Sans" pitchFamily="34" charset="-120"/>
+                <a:latin typeface="Times New Roman" pitchFamily="34" charset="0"/>
+                <a:ea typeface="Times New Roman" pitchFamily="34" charset="-122"/>
+                <a:cs typeface="Times New Roman" pitchFamily="34" charset="-120"/>
               </a:rPr>
               <a:t>Slide 8 / 10 • Full-Stack REST API Architecture</a:t>
             </a:r>
@@ -12469,9 +12442,9 @@
                 <a:solidFill>
                   <a:srgbClr val="7C3AED"/>
                 </a:solidFill>
-                <a:latin typeface="Plus Jakarta Sans" pitchFamily="34" charset="0"/>
-                <a:ea typeface="Plus Jakarta Sans" pitchFamily="34" charset="-122"/>
-                <a:cs typeface="Plus Jakarta Sans" pitchFamily="34" charset="-120"/>
+                <a:latin typeface="Times New Roman" pitchFamily="34" charset="0"/>
+                <a:ea typeface="Times New Roman" pitchFamily="34" charset="-122"/>
+                <a:cs typeface="Times New Roman" pitchFamily="34" charset="-120"/>
               </a:rPr>
               <a:t>AI INTELLIGENCE SUITE</a:t>
             </a:r>
@@ -12508,9 +12481,9 @@
                 <a:solidFill>
                   <a:srgbClr val="261E38"/>
                 </a:solidFill>
-                <a:latin typeface="Outfit" pitchFamily="34" charset="0"/>
-                <a:ea typeface="Outfit" pitchFamily="34" charset="-122"/>
-                <a:cs typeface="Outfit" pitchFamily="34" charset="-120"/>
+                <a:latin typeface="Times New Roman" pitchFamily="34" charset="0"/>
+                <a:ea typeface="Times New Roman" pitchFamily="34" charset="-122"/>
+                <a:cs typeface="Times New Roman" pitchFamily="34" charset="-120"/>
               </a:rPr>
               <a:t>PawDoctor 24/7 Symptom Triage Engine API</a:t>
             </a:r>
@@ -12570,9 +12543,9 @@
                 <a:solidFill>
                   <a:srgbClr val="9589B0"/>
                 </a:solidFill>
-                <a:latin typeface="Plus Jakarta Sans" pitchFamily="34" charset="0"/>
-                <a:ea typeface="Plus Jakarta Sans" pitchFamily="34" charset="-122"/>
-                <a:cs typeface="Plus Jakarta Sans" pitchFamily="34" charset="-120"/>
+                <a:latin typeface="Times New Roman" pitchFamily="34" charset="0"/>
+                <a:ea typeface="Times New Roman" pitchFamily="34" charset="-122"/>
+                <a:cs typeface="Times New Roman" pitchFamily="34" charset="-120"/>
               </a:rPr>
               <a:t>Nuzzle API v2.0 • Abu Zafor, Nadim Rahman, Rizvi Sarker • Technopreneurship 2026</a:t>
             </a:r>
@@ -12634,9 +12607,9 @@
                 <a:solidFill>
                   <a:srgbClr val="7C3AED"/>
                 </a:solidFill>
-                <a:latin typeface="Plus Jakarta Sans" pitchFamily="34" charset="0"/>
-                <a:ea typeface="Plus Jakarta Sans" pitchFamily="34" charset="-122"/>
-                <a:cs typeface="Plus Jakarta Sans" pitchFamily="34" charset="-120"/>
+                <a:latin typeface="Times New Roman" pitchFamily="34" charset="0"/>
+                <a:ea typeface="Times New Roman" pitchFamily="34" charset="-122"/>
+                <a:cs typeface="Times New Roman" pitchFamily="34" charset="-120"/>
               </a:rPr>
               <a:t>CLINICAL TRIAGE CLASSIFICATION</a:t>
             </a:r>
@@ -12698,9 +12671,9 @@
                 <a:solidFill>
                   <a:srgbClr val="F43F5E"/>
                 </a:solidFill>
-                <a:latin typeface="Outfit" pitchFamily="34" charset="0"/>
-                <a:ea typeface="Outfit" pitchFamily="34" charset="-122"/>
-                <a:cs typeface="Outfit" pitchFamily="34" charset="-120"/>
+                <a:latin typeface="Times New Roman" pitchFamily="34" charset="0"/>
+                <a:ea typeface="Times New Roman" pitchFamily="34" charset="-122"/>
+                <a:cs typeface="Times New Roman" pitchFamily="34" charset="-120"/>
               </a:rPr>
               <a:t>🚨 EMERGENCY (Critical)</a:t>
             </a:r>
@@ -12740,9 +12713,9 @@
                 <a:solidFill>
                   <a:srgbClr val="5F5377"/>
                 </a:solidFill>
-                <a:latin typeface="Plus Jakarta Sans" pitchFamily="34" charset="0"/>
-                <a:ea typeface="Plus Jakarta Sans" pitchFamily="34" charset="-122"/>
-                <a:cs typeface="Plus Jakarta Sans" pitchFamily="34" charset="-120"/>
+                <a:latin typeface="Times New Roman" pitchFamily="34" charset="0"/>
+                <a:ea typeface="Times New Roman" pitchFamily="34" charset="-122"/>
+                <a:cs typeface="Times New Roman" pitchFamily="34" charset="-120"/>
               </a:rPr>
               <a:t>Toxins (chocolate, poison, grapes), uncontrolled bleeding, trauma. Triggers immediate 24/7 emergency clinic dispatch.</a:t>
             </a:r>
@@ -12804,9 +12777,9 @@
                 <a:solidFill>
                   <a:srgbClr val="F59E0B"/>
                 </a:solidFill>
-                <a:latin typeface="Outfit" pitchFamily="34" charset="0"/>
-                <a:ea typeface="Outfit" pitchFamily="34" charset="-122"/>
-                <a:cs typeface="Outfit" pitchFamily="34" charset="-120"/>
+                <a:latin typeface="Times New Roman" pitchFamily="34" charset="0"/>
+                <a:ea typeface="Times New Roman" pitchFamily="34" charset="-122"/>
+                <a:cs typeface="Times New Roman" pitchFamily="34" charset="-120"/>
               </a:rPr>
               <a:t>⚠️ MODERATE (Clinical Attention)</a:t>
             </a:r>
@@ -12846,9 +12819,9 @@
                 <a:solidFill>
                   <a:srgbClr val="5F5377"/>
                 </a:solidFill>
-                <a:latin typeface="Plus Jakarta Sans" pitchFamily="34" charset="0"/>
-                <a:ea typeface="Plus Jakarta Sans" pitchFamily="34" charset="-122"/>
-                <a:cs typeface="Plus Jakarta Sans" pitchFamily="34" charset="-120"/>
+                <a:latin typeface="Times New Roman" pitchFamily="34" charset="0"/>
+                <a:ea typeface="Times New Roman" pitchFamily="34" charset="-122"/>
+                <a:cs typeface="Times New Roman" pitchFamily="34" charset="-120"/>
               </a:rPr>
               <a:t>Limping, repeated vomiting, diarrhea, lethargy. Suggests withholding food for 4h and booking quick checkup.</a:t>
             </a:r>
@@ -12910,9 +12883,9 @@
                 <a:solidFill>
                   <a:srgbClr val="10B981"/>
                 </a:solidFill>
-                <a:latin typeface="Outfit" pitchFamily="34" charset="0"/>
-                <a:ea typeface="Outfit" pitchFamily="34" charset="-122"/>
-                <a:cs typeface="Outfit" pitchFamily="34" charset="-120"/>
+                <a:latin typeface="Times New Roman" pitchFamily="34" charset="0"/>
+                <a:ea typeface="Times New Roman" pitchFamily="34" charset="-122"/>
+                <a:cs typeface="Times New Roman" pitchFamily="34" charset="-120"/>
               </a:rPr>
               <a:t>🌿 LOW / WELLNESS (Guidance)</a:t>
             </a:r>
@@ -12952,9 +12925,9 @@
                 <a:solidFill>
                   <a:srgbClr val="5F5377"/>
                 </a:solidFill>
-                <a:latin typeface="Plus Jakarta Sans" pitchFamily="34" charset="0"/>
-                <a:ea typeface="Plus Jakarta Sans" pitchFamily="34" charset="-122"/>
-                <a:cs typeface="Plus Jakarta Sans" pitchFamily="34" charset="-120"/>
+                <a:latin typeface="Times New Roman" pitchFamily="34" charset="0"/>
+                <a:ea typeface="Times New Roman" pitchFamily="34" charset="-122"/>
+                <a:cs typeface="Times New Roman" pitchFamily="34" charset="-120"/>
               </a:rPr>
               <a:t>Nutrition, dietary caloric calculation, coat health, preventive care tips in Bangla &amp; English.</a:t>
             </a:r>
@@ -13543,9 +13516,9 @@
                 <a:solidFill>
                   <a:srgbClr val="7C3AED"/>
                 </a:solidFill>
-                <a:latin typeface="Outfit" pitchFamily="34" charset="0"/>
-                <a:ea typeface="Outfit" pitchFamily="34" charset="-122"/>
-                <a:cs typeface="Outfit" pitchFamily="34" charset="-120"/>
+                <a:latin typeface="Times New Roman" pitchFamily="34" charset="0"/>
+                <a:ea typeface="Times New Roman" pitchFamily="34" charset="-122"/>
+                <a:cs typeface="Times New Roman" pitchFamily="34" charset="-120"/>
               </a:rPr>
               <a:t>🐾 Nuzzle Engine</a:t>
             </a:r>
@@ -13582,9 +13555,9 @@
                 <a:solidFill>
                   <a:srgbClr val="5F5377"/>
                 </a:solidFill>
-                <a:latin typeface="Plus Jakarta Sans" pitchFamily="34" charset="0"/>
-                <a:ea typeface="Plus Jakarta Sans" pitchFamily="34" charset="-122"/>
-                <a:cs typeface="Plus Jakarta Sans" pitchFamily="34" charset="-120"/>
+                <a:latin typeface="Times New Roman" pitchFamily="34" charset="0"/>
+                <a:ea typeface="Times New Roman" pitchFamily="34" charset="-122"/>
+                <a:cs typeface="Times New Roman" pitchFamily="34" charset="-120"/>
               </a:rPr>
               <a:t>Slide 9 / 10 • Full-Stack REST API Architecture</a:t>
             </a:r>
@@ -13621,9 +13594,9 @@
                 <a:solidFill>
                   <a:srgbClr val="7C3AED"/>
                 </a:solidFill>
-                <a:latin typeface="Plus Jakarta Sans" pitchFamily="34" charset="0"/>
-                <a:ea typeface="Plus Jakarta Sans" pitchFamily="34" charset="-122"/>
-                <a:cs typeface="Plus Jakarta Sans" pitchFamily="34" charset="-120"/>
+                <a:latin typeface="Times New Roman" pitchFamily="34" charset="0"/>
+                <a:ea typeface="Times New Roman" pitchFamily="34" charset="-122"/>
+                <a:cs typeface="Times New Roman" pitchFamily="34" charset="-120"/>
               </a:rPr>
               <a:t>CLIENT INTEGRATION LAYER</a:t>
             </a:r>
@@ -13660,9 +13633,9 @@
                 <a:solidFill>
                   <a:srgbClr val="261E38"/>
                 </a:solidFill>
-                <a:latin typeface="Outfit" pitchFamily="34" charset="0"/>
-                <a:ea typeface="Outfit" pitchFamily="34" charset="-122"/>
-                <a:cs typeface="Outfit" pitchFamily="34" charset="-120"/>
+                <a:latin typeface="Times New Roman" pitchFamily="34" charset="0"/>
+                <a:ea typeface="Times New Roman" pitchFamily="34" charset="-122"/>
+                <a:cs typeface="Times New Roman" pitchFamily="34" charset="-120"/>
               </a:rPr>
               <a:t>Frontend Service Architecture &amp; Reactive State Synchronization</a:t>
             </a:r>
@@ -13722,9 +13695,9 @@
                 <a:solidFill>
                   <a:srgbClr val="9589B0"/>
                 </a:solidFill>
-                <a:latin typeface="Plus Jakarta Sans" pitchFamily="34" charset="0"/>
-                <a:ea typeface="Plus Jakarta Sans" pitchFamily="34" charset="-122"/>
-                <a:cs typeface="Plus Jakarta Sans" pitchFamily="34" charset="-120"/>
+                <a:latin typeface="Times New Roman" pitchFamily="34" charset="0"/>
+                <a:ea typeface="Times New Roman" pitchFamily="34" charset="-122"/>
+                <a:cs typeface="Times New Roman" pitchFamily="34" charset="-120"/>
               </a:rPr>
               <a:t>Nuzzle API v2.0 • Abu Zafor, Nadim Rahman, Rizvi Sarker • Technopreneurship 2026</a:t>
             </a:r>
@@ -13786,9 +13759,9 @@
                 <a:solidFill>
                   <a:srgbClr val="7C3AED"/>
                 </a:solidFill>
-                <a:latin typeface="Outfit" pitchFamily="34" charset="0"/>
-                <a:ea typeface="Outfit" pitchFamily="34" charset="-122"/>
-                <a:cs typeface="Outfit" pitchFamily="34" charset="-120"/>
+                <a:latin typeface="Times New Roman" pitchFamily="34" charset="0"/>
+                <a:ea typeface="Times New Roman" pitchFamily="34" charset="-122"/>
+                <a:cs typeface="Times New Roman" pitchFamily="34" charset="-120"/>
               </a:rPr>
               <a:t>apiClient.ts (Core HTTP Client)</a:t>
             </a:r>
@@ -13828,9 +13801,9 @@
                 <a:solidFill>
                   <a:srgbClr val="5F5377"/>
                 </a:solidFill>
-                <a:latin typeface="Plus Jakarta Sans" pitchFamily="34" charset="0"/>
-                <a:ea typeface="Plus Jakarta Sans" pitchFamily="34" charset="-122"/>
-                <a:cs typeface="Plus Jakarta Sans" pitchFamily="34" charset="-120"/>
+                <a:latin typeface="Times New Roman" pitchFamily="34" charset="0"/>
+                <a:ea typeface="Times New Roman" pitchFamily="34" charset="-122"/>
+                <a:cs typeface="Times New Roman" pitchFamily="34" charset="-120"/>
               </a:rPr>
               <a:t>Base fetch client supporting Bearer token headers, standard JSON unwrapping, timeout guards, and Vite proxy.</a:t>
             </a:r>
@@ -13999,9 +13972,9 @@
                 <a:solidFill>
                   <a:srgbClr val="7C3AED"/>
                 </a:solidFill>
-                <a:latin typeface="Outfit" pitchFamily="34" charset="0"/>
-                <a:ea typeface="Outfit" pitchFamily="34" charset="-122"/>
-                <a:cs typeface="Outfit" pitchFamily="34" charset="-120"/>
+                <a:latin typeface="Times New Roman" pitchFamily="34" charset="0"/>
+                <a:ea typeface="Times New Roman" pitchFamily="34" charset="-122"/>
+                <a:cs typeface="Times New Roman" pitchFamily="34" charset="-120"/>
               </a:rPr>
               <a:t>Domain Service Modules</a:t>
             </a:r>
@@ -14041,9 +14014,9 @@
                 <a:solidFill>
                   <a:srgbClr val="5F5377"/>
                 </a:solidFill>
-                <a:latin typeface="Plus Jakarta Sans" pitchFamily="34" charset="0"/>
-                <a:ea typeface="Plus Jakarta Sans" pitchFamily="34" charset="-122"/>
-                <a:cs typeface="Plus Jakarta Sans" pitchFamily="34" charset="-120"/>
+                <a:latin typeface="Times New Roman" pitchFamily="34" charset="0"/>
+                <a:ea typeface="Times New Roman" pitchFamily="34" charset="-122"/>
+                <a:cs typeface="Times New Roman" pitchFamily="34" charset="-120"/>
               </a:rPr>
               <a:t>Modular services encapsulating each business domain: authService, postService, petService, vetService, pawAiService.</a:t>
             </a:r>
@@ -14212,9 +14185,9 @@
                 <a:solidFill>
                   <a:srgbClr val="7C3AED"/>
                 </a:solidFill>
-                <a:latin typeface="Outfit" pitchFamily="34" charset="0"/>
-                <a:ea typeface="Outfit" pitchFamily="34" charset="-122"/>
-                <a:cs typeface="Outfit" pitchFamily="34" charset="-120"/>
+                <a:latin typeface="Times New Roman" pitchFamily="34" charset="0"/>
+                <a:ea typeface="Times New Roman" pitchFamily="34" charset="-122"/>
+                <a:cs typeface="Times New Roman" pitchFamily="34" charset="-120"/>
               </a:rPr>
               <a:t>appStore.ts Reactive Sync</a:t>
             </a:r>
@@ -14254,9 +14227,9 @@
                 <a:solidFill>
                   <a:srgbClr val="5F5377"/>
                 </a:solidFill>
-                <a:latin typeface="Plus Jakarta Sans" pitchFamily="34" charset="0"/>
-                <a:ea typeface="Plus Jakarta Sans" pitchFamily="34" charset="-122"/>
-                <a:cs typeface="Plus Jakarta Sans" pitchFamily="34" charset="-120"/>
+                <a:latin typeface="Times New Roman" pitchFamily="34" charset="0"/>
+                <a:ea typeface="Times New Roman" pitchFamily="34" charset="-122"/>
+                <a:cs typeface="Times New Roman" pitchFamily="34" charset="-120"/>
               </a:rPr>
               <a:t>Vue reactive store performs optimistic mutations immediately for zero-lag UI, then asynchronously syncs to backend API.</a:t>
             </a:r>
@@ -14405,9 +14378,9 @@
                 <a:solidFill>
                   <a:srgbClr val="7C3AED"/>
                 </a:solidFill>
-                <a:latin typeface="Outfit" pitchFamily="34" charset="0"/>
-                <a:ea typeface="Outfit" pitchFamily="34" charset="-122"/>
-                <a:cs typeface="Outfit" pitchFamily="34" charset="-120"/>
+                <a:latin typeface="Times New Roman" pitchFamily="34" charset="0"/>
+                <a:ea typeface="Times New Roman" pitchFamily="34" charset="-122"/>
+                <a:cs typeface="Times New Roman" pitchFamily="34" charset="-120"/>
               </a:rPr>
               <a:t>Vite Dev Proxy Configuration</a:t>
             </a:r>
@@ -14447,9 +14420,9 @@
                 <a:solidFill>
                   <a:srgbClr val="5F5377"/>
                 </a:solidFill>
-                <a:latin typeface="Plus Jakarta Sans" pitchFamily="34" charset="0"/>
-                <a:ea typeface="Plus Jakarta Sans" pitchFamily="34" charset="-122"/>
-                <a:cs typeface="Plus Jakarta Sans" pitchFamily="34" charset="-120"/>
+                <a:latin typeface="Times New Roman" pitchFamily="34" charset="0"/>
+                <a:ea typeface="Times New Roman" pitchFamily="34" charset="-122"/>
+                <a:cs typeface="Times New Roman" pitchFamily="34" charset="-120"/>
               </a:rPr>
               <a:t>vite.config.ts automatically proxies all /api requests to http://localhost:3000 for seamless local development with 0 CORS.</a:t>
             </a:r>

</xml_diff>